<commit_message>
Review phase 6: downloads rebuilt; trades and services never mixed; generated stamps and full download names; made-with notes
Excel: native charts, tables, named headline numbers, points and direction colours, Roboto on every cell.
PowerPoint: real layouts and theme, one slide per topic, target and break-even lines, speaker notes.
PDF: dollar shortfall instead of ticks, tables flow, no forced page gaps.
Separation: per-business growth downloads, business named in every working, Power BI one-business guards,
tools/tests/org_separation.py.

Co-Authored-By: Claude Opus 5.5 <noreply@anthropic.com>
</commit_message>
<xml_diff>
--- a/media/exports/deliveries-sample.pptx
+++ b/media/exports/deliveries-sample.pptx
@@ -6,12 +6,12 @@
   </p:sldMasterIdLst>
   <p:sldIdLst>
     <p:sldId id="256" r:id="rId7"/>
-    <p:sldId id="257" r:id="rId8"/>
-    <p:sldId id="258" r:id="rId9"/>
-    <p:sldId id="259" r:id="rId10"/>
-    <p:sldId id="260" r:id="rId11"/>
-    <p:sldId id="261" r:id="rId12"/>
-    <p:sldId id="262" r:id="rId13"/>
+    <p:sldId id="257" r:id="rId9"/>
+    <p:sldId id="258" r:id="rId10"/>
+    <p:sldId id="259" r:id="rId11"/>
+    <p:sldId id="260" r:id="rId12"/>
+    <p:sldId id="261" r:id="rId13"/>
+    <p:sldId id="262" r:id="rId14"/>
   </p:sldIdLst>
   <p:sldSz cx="12191695" cy="6858000" type="screen4x3"/>
   <p:notesSz cx="6858000" cy="9144000"/>
@@ -111,6 +111,846 @@
     </a:lvl9pPr>
   </p:defaultTextStyle>
 </p:presentation>
+</file>
+
+<file path=ppt/notesMasters/notesMaster1.xml><?xml version="1.0" encoding="utf-8"?>
+<p:notesMaster xmlns:a="http://schemas.openxmlformats.org/drawingml/2006/main" xmlns:p="http://schemas.openxmlformats.org/presentationml/2006/main" xmlns:r="http://schemas.openxmlformats.org/officeDocument/2006/relationships">
+  <p:cSld>
+    <p:bg>
+      <p:bgRef idx="1001">
+        <a:schemeClr val="bg1"/>
+      </p:bgRef>
+    </p:bg>
+    <p:spTree>
+      <p:nvGrpSpPr>
+        <p:cNvPr id="1" name=""/>
+        <p:cNvGrpSpPr/>
+        <p:nvPr/>
+      </p:nvGrpSpPr>
+      <p:grpSpPr>
+        <a:xfrm>
+          <a:off x="0" y="0"/>
+          <a:ext cx="0" cy="0"/>
+          <a:chOff x="0" y="0"/>
+          <a:chExt cx="0" cy="0"/>
+        </a:xfrm>
+      </p:grpSpPr>
+      <p:sp>
+        <p:nvSpPr>
+          <p:cNvPr id="2" name="Header Placeholder 1"/>
+          <p:cNvSpPr>
+            <a:spLocks noGrp="1"/>
+          </p:cNvSpPr>
+          <p:nvPr>
+            <p:ph type="hdr" sz="quarter"/>
+          </p:nvPr>
+        </p:nvSpPr>
+        <p:spPr>
+          <a:xfrm>
+            <a:off x="0" y="0"/>
+            <a:ext cx="2971800" cy="457200"/>
+          </a:xfrm>
+          <a:prstGeom prst="rect">
+            <a:avLst/>
+          </a:prstGeom>
+        </p:spPr>
+        <p:txBody>
+          <a:bodyPr vert="horz" lIns="91440" tIns="45720" rIns="91440" bIns="45720" rtlCol="0"/>
+          <a:lstStyle>
+            <a:lvl1pPr algn="l">
+              <a:defRPr sz="1200"/>
+            </a:lvl1pPr>
+          </a:lstStyle>
+          <a:p>
+            <a:endParaRPr lang="en-US"/>
+          </a:p>
+        </p:txBody>
+      </p:sp>
+      <p:sp>
+        <p:nvSpPr>
+          <p:cNvPr id="3" name="Date Placeholder 2"/>
+          <p:cNvSpPr>
+            <a:spLocks noGrp="1"/>
+          </p:cNvSpPr>
+          <p:nvPr>
+            <p:ph type="dt" idx="1"/>
+          </p:nvPr>
+        </p:nvSpPr>
+        <p:spPr>
+          <a:xfrm>
+            <a:off x="3884613" y="0"/>
+            <a:ext cx="2971800" cy="457200"/>
+          </a:xfrm>
+          <a:prstGeom prst="rect">
+            <a:avLst/>
+          </a:prstGeom>
+        </p:spPr>
+        <p:txBody>
+          <a:bodyPr vert="horz" lIns="91440" tIns="45720" rIns="91440" bIns="45720" rtlCol="0"/>
+          <a:lstStyle>
+            <a:lvl1pPr algn="r">
+              <a:defRPr sz="1200"/>
+            </a:lvl1pPr>
+          </a:lstStyle>
+          <a:p>
+            <a:fld id="{0F89C1C7-3DCD-1040-A9CF-14679D8B5DDD}" type="datetimeFigureOut">
+              <a:rPr lang="en-US" smtClean="0"/>
+              <a:t>10/17/16</a:t>
+            </a:fld>
+            <a:endParaRPr lang="en-US"/>
+          </a:p>
+        </p:txBody>
+      </p:sp>
+      <p:sp>
+        <p:nvSpPr>
+          <p:cNvPr id="4" name="Slide Image Placeholder 3"/>
+          <p:cNvSpPr>
+            <a:spLocks noGrp="1" noRot="1" noChangeAspect="1"/>
+          </p:cNvSpPr>
+          <p:nvPr>
+            <p:ph type="sldImg" idx="2"/>
+          </p:nvPr>
+        </p:nvSpPr>
+        <p:spPr>
+          <a:xfrm>
+            <a:off x="1143000" y="685800"/>
+            <a:ext cx="4572000" cy="3429000"/>
+          </a:xfrm>
+          <a:prstGeom prst="rect">
+            <a:avLst/>
+          </a:prstGeom>
+          <a:noFill/>
+          <a:ln w="12700">
+            <a:solidFill>
+              <a:prstClr val="black"/>
+            </a:solidFill>
+          </a:ln>
+        </p:spPr>
+        <p:txBody>
+          <a:bodyPr vert="horz" lIns="91440" tIns="45720" rIns="91440" bIns="45720" rtlCol="0" anchor="ctr"/>
+          <a:lstStyle/>
+          <a:p>
+            <a:endParaRPr lang="en-US"/>
+          </a:p>
+        </p:txBody>
+      </p:sp>
+      <p:sp>
+        <p:nvSpPr>
+          <p:cNvPr id="5" name="Notes Placeholder 4"/>
+          <p:cNvSpPr>
+            <a:spLocks noGrp="1"/>
+          </p:cNvSpPr>
+          <p:nvPr>
+            <p:ph type="body" sz="quarter" idx="3"/>
+          </p:nvPr>
+        </p:nvSpPr>
+        <p:spPr>
+          <a:xfrm>
+            <a:off x="685800" y="4343400"/>
+            <a:ext cx="5486400" cy="4114800"/>
+          </a:xfrm>
+          <a:prstGeom prst="rect">
+            <a:avLst/>
+          </a:prstGeom>
+        </p:spPr>
+        <p:txBody>
+          <a:bodyPr vert="horz" lIns="91440" tIns="45720" rIns="91440" bIns="45720" rtlCol="0"/>
+          <a:lstStyle/>
+          <a:p>
+            <a:pPr lvl="0"/>
+            <a:r>
+              <a:rPr lang="en-US" smtClean="0"/>
+              <a:t>Click to edit Master text styles</a:t>
+            </a:r>
+          </a:p>
+          <a:p>
+            <a:pPr lvl="1"/>
+            <a:r>
+              <a:rPr lang="en-US" smtClean="0"/>
+              <a:t>Second level</a:t>
+            </a:r>
+          </a:p>
+          <a:p>
+            <a:pPr lvl="2"/>
+            <a:r>
+              <a:rPr lang="en-US" smtClean="0"/>
+              <a:t>Third level</a:t>
+            </a:r>
+          </a:p>
+          <a:p>
+            <a:pPr lvl="3"/>
+            <a:r>
+              <a:rPr lang="en-US" smtClean="0"/>
+              <a:t>Fourth level</a:t>
+            </a:r>
+          </a:p>
+          <a:p>
+            <a:pPr lvl="4"/>
+            <a:r>
+              <a:rPr lang="en-US" smtClean="0"/>
+              <a:t>Fifth level</a:t>
+            </a:r>
+            <a:endParaRPr lang="en-US"/>
+          </a:p>
+        </p:txBody>
+      </p:sp>
+      <p:sp>
+        <p:nvSpPr>
+          <p:cNvPr id="6" name="Footer Placeholder 5"/>
+          <p:cNvSpPr>
+            <a:spLocks noGrp="1"/>
+          </p:cNvSpPr>
+          <p:nvPr>
+            <p:ph type="ftr" sz="quarter" idx="4"/>
+          </p:nvPr>
+        </p:nvSpPr>
+        <p:spPr>
+          <a:xfrm>
+            <a:off x="0" y="8685213"/>
+            <a:ext cx="2971800" cy="457200"/>
+          </a:xfrm>
+          <a:prstGeom prst="rect">
+            <a:avLst/>
+          </a:prstGeom>
+        </p:spPr>
+        <p:txBody>
+          <a:bodyPr vert="horz" lIns="91440" tIns="45720" rIns="91440" bIns="45720" rtlCol="0" anchor="b"/>
+          <a:lstStyle>
+            <a:lvl1pPr algn="l">
+              <a:defRPr sz="1200"/>
+            </a:lvl1pPr>
+          </a:lstStyle>
+          <a:p>
+            <a:endParaRPr lang="en-US"/>
+          </a:p>
+        </p:txBody>
+      </p:sp>
+      <p:sp>
+        <p:nvSpPr>
+          <p:cNvPr id="7" name="Slide Number Placeholder 6"/>
+          <p:cNvSpPr>
+            <a:spLocks noGrp="1"/>
+          </p:cNvSpPr>
+          <p:nvPr>
+            <p:ph type="sldNum" sz="quarter" idx="5"/>
+          </p:nvPr>
+        </p:nvSpPr>
+        <p:spPr>
+          <a:xfrm>
+            <a:off x="3884613" y="8685213"/>
+            <a:ext cx="2971800" cy="457200"/>
+          </a:xfrm>
+          <a:prstGeom prst="rect">
+            <a:avLst/>
+          </a:prstGeom>
+        </p:spPr>
+        <p:txBody>
+          <a:bodyPr vert="horz" lIns="91440" tIns="45720" rIns="91440" bIns="45720" rtlCol="0" anchor="b"/>
+          <a:lstStyle>
+            <a:lvl1pPr algn="r">
+              <a:defRPr sz="1200"/>
+            </a:lvl1pPr>
+          </a:lstStyle>
+          <a:p>
+            <a:fld id="{BB5E49A5-4136-284D-997B-48E1D791AD67}" type="slidenum">
+              <a:rPr lang="en-US" smtClean="0"/>
+              <a:t>‹#›</a:t>
+            </a:fld>
+            <a:endParaRPr lang="en-US"/>
+          </a:p>
+        </p:txBody>
+      </p:sp>
+    </p:spTree>
+    <p:extLst>
+      <p:ext uri="{BB962C8B-B14F-4D97-AF65-F5344CB8AC3E}">
+        <p14:creationId xmlns:p14="http://schemas.microsoft.com/office/powerpoint/2010/main" val="2623252185"/>
+      </p:ext>
+    </p:extLst>
+  </p:cSld>
+  <p:clrMap bg1="lt1" tx1="dk1" bg2="lt2" tx2="dk2" accent1="accent1" accent2="accent2" accent3="accent3" accent4="accent4" accent5="accent5" accent6="accent6" hlink="hlink" folHlink="folHlink"/>
+  <p:notesStyle>
+    <a:lvl1pPr marL="0" algn="l" defTabSz="457200" rtl="0" eaLnBrk="1" latinLnBrk="0" hangingPunct="1">
+      <a:defRPr sz="1200" kern="1200">
+        <a:solidFill>
+          <a:schemeClr val="tx1"/>
+        </a:solidFill>
+        <a:latin typeface="+mn-lt"/>
+        <a:ea typeface="+mn-ea"/>
+        <a:cs typeface="+mn-cs"/>
+      </a:defRPr>
+    </a:lvl1pPr>
+    <a:lvl2pPr marL="457200" algn="l" defTabSz="457200" rtl="0" eaLnBrk="1" latinLnBrk="0" hangingPunct="1">
+      <a:defRPr sz="1200" kern="1200">
+        <a:solidFill>
+          <a:schemeClr val="tx1"/>
+        </a:solidFill>
+        <a:latin typeface="+mn-lt"/>
+        <a:ea typeface="+mn-ea"/>
+        <a:cs typeface="+mn-cs"/>
+      </a:defRPr>
+    </a:lvl2pPr>
+    <a:lvl3pPr marL="914400" algn="l" defTabSz="457200" rtl="0" eaLnBrk="1" latinLnBrk="0" hangingPunct="1">
+      <a:defRPr sz="1200" kern="1200">
+        <a:solidFill>
+          <a:schemeClr val="tx1"/>
+        </a:solidFill>
+        <a:latin typeface="+mn-lt"/>
+        <a:ea typeface="+mn-ea"/>
+        <a:cs typeface="+mn-cs"/>
+      </a:defRPr>
+    </a:lvl3pPr>
+    <a:lvl4pPr marL="1371600" algn="l" defTabSz="457200" rtl="0" eaLnBrk="1" latinLnBrk="0" hangingPunct="1">
+      <a:defRPr sz="1200" kern="1200">
+        <a:solidFill>
+          <a:schemeClr val="tx1"/>
+        </a:solidFill>
+        <a:latin typeface="+mn-lt"/>
+        <a:ea typeface="+mn-ea"/>
+        <a:cs typeface="+mn-cs"/>
+      </a:defRPr>
+    </a:lvl4pPr>
+    <a:lvl5pPr marL="1828800" algn="l" defTabSz="457200" rtl="0" eaLnBrk="1" latinLnBrk="0" hangingPunct="1">
+      <a:defRPr sz="1200" kern="1200">
+        <a:solidFill>
+          <a:schemeClr val="tx1"/>
+        </a:solidFill>
+        <a:latin typeface="+mn-lt"/>
+        <a:ea typeface="+mn-ea"/>
+        <a:cs typeface="+mn-cs"/>
+      </a:defRPr>
+    </a:lvl5pPr>
+    <a:lvl6pPr marL="2286000" algn="l" defTabSz="457200" rtl="0" eaLnBrk="1" latinLnBrk="0" hangingPunct="1">
+      <a:defRPr sz="1200" kern="1200">
+        <a:solidFill>
+          <a:schemeClr val="tx1"/>
+        </a:solidFill>
+        <a:latin typeface="+mn-lt"/>
+        <a:ea typeface="+mn-ea"/>
+        <a:cs typeface="+mn-cs"/>
+      </a:defRPr>
+    </a:lvl6pPr>
+    <a:lvl7pPr marL="2743200" algn="l" defTabSz="457200" rtl="0" eaLnBrk="1" latinLnBrk="0" hangingPunct="1">
+      <a:defRPr sz="1200" kern="1200">
+        <a:solidFill>
+          <a:schemeClr val="tx1"/>
+        </a:solidFill>
+        <a:latin typeface="+mn-lt"/>
+        <a:ea typeface="+mn-ea"/>
+        <a:cs typeface="+mn-cs"/>
+      </a:defRPr>
+    </a:lvl7pPr>
+    <a:lvl8pPr marL="3200400" algn="l" defTabSz="457200" rtl="0" eaLnBrk="1" latinLnBrk="0" hangingPunct="1">
+      <a:defRPr sz="1200" kern="1200">
+        <a:solidFill>
+          <a:schemeClr val="tx1"/>
+        </a:solidFill>
+        <a:latin typeface="+mn-lt"/>
+        <a:ea typeface="+mn-ea"/>
+        <a:cs typeface="+mn-cs"/>
+      </a:defRPr>
+    </a:lvl8pPr>
+    <a:lvl9pPr marL="3657600" algn="l" defTabSz="457200" rtl="0" eaLnBrk="1" latinLnBrk="0" hangingPunct="1">
+      <a:defRPr sz="1200" kern="1200">
+        <a:solidFill>
+          <a:schemeClr val="tx1"/>
+        </a:solidFill>
+        <a:latin typeface="+mn-lt"/>
+        <a:ea typeface="+mn-ea"/>
+        <a:cs typeface="+mn-cs"/>
+      </a:defRPr>
+    </a:lvl9pPr>
+  </p:notesStyle>
+</p:notesMaster>
+</file>
+
+<file path=ppt/notesSlides/notesSlide1.xml><?xml version="1.0" encoding="utf-8"?>
+<p:notes xmlns:a="http://schemas.openxmlformats.org/drawingml/2006/main" xmlns:p="http://schemas.openxmlformats.org/presentationml/2006/main" xmlns:r="http://schemas.openxmlformats.org/officeDocument/2006/relationships">
+  <p:cSld>
+    <p:spTree>
+      <p:nvGrpSpPr>
+        <p:cNvPr id="1" name=""/>
+        <p:cNvGrpSpPr/>
+        <p:nvPr/>
+      </p:nvGrpSpPr>
+      <p:grpSpPr>
+        <a:xfrm>
+          <a:off x="0" y="0"/>
+          <a:ext cx="0" cy="0"/>
+          <a:chOff x="0" y="0"/>
+          <a:chExt cx="0" cy="0"/>
+        </a:xfrm>
+      </p:grpSpPr>
+      <p:sp>
+        <p:nvSpPr>
+          <p:cNvPr id="2" name="Slide Image Placeholder 1"/>
+          <p:cNvSpPr>
+            <a:spLocks noGrp="1"/>
+          </p:cNvSpPr>
+          <p:nvPr>
+            <p:ph type="sldImg" idx="2"/>
+          </p:nvPr>
+        </p:nvSpPr>
+        <p:spPr/>
+      </p:sp>
+      <p:sp>
+        <p:nvSpPr>
+          <p:cNvPr id="3" name="Notes Placeholder 2"/>
+          <p:cNvSpPr>
+            <a:spLocks noGrp="1"/>
+          </p:cNvSpPr>
+          <p:nvPr>
+            <p:ph type="body" idx="3" sz="quarter"/>
+          </p:nvPr>
+        </p:nvSpPr>
+        <p:spPr/>
+        <p:txBody>
+          <a:bodyPr/>
+          <a:lstStyle/>
+          <a:p>
+            <a:r>
+              <a:t>Deliveries in and out. Sample Distribution Pty Ltd. Every delivery out to a customer and in from a supplier, for an invented distribution centre at Wacol, Brisbane.</a:t>
+            </a:r>
+          </a:p>
+        </p:txBody>
+      </p:sp>
+      <p:sp>
+        <p:nvSpPr>
+          <p:cNvPr id="4" name="Slide Number Placeholder 3"/>
+          <p:cNvSpPr>
+            <a:spLocks noGrp="1"/>
+          </p:cNvSpPr>
+          <p:nvPr>
+            <p:ph type="sldNum" idx="5" sz="quarter"/>
+          </p:nvPr>
+        </p:nvSpPr>
+        <p:spPr/>
+      </p:sp>
+    </p:spTree>
+  </p:cSld>
+  <p:clrMapOvr>
+    <a:masterClrMapping/>
+  </p:clrMapOvr>
+</p:notes>
+</file>
+
+<file path=ppt/notesSlides/notesSlide2.xml><?xml version="1.0" encoding="utf-8"?>
+<p:notes xmlns:a="http://schemas.openxmlformats.org/drawingml/2006/main" xmlns:p="http://schemas.openxmlformats.org/presentationml/2006/main" xmlns:r="http://schemas.openxmlformats.org/officeDocument/2006/relationships">
+  <p:cSld>
+    <p:spTree>
+      <p:nvGrpSpPr>
+        <p:cNvPr id="1" name=""/>
+        <p:cNvGrpSpPr/>
+        <p:nvPr/>
+      </p:nvGrpSpPr>
+      <p:grpSpPr>
+        <a:xfrm>
+          <a:off x="0" y="0"/>
+          <a:ext cx="0" cy="0"/>
+          <a:chOff x="0" y="0"/>
+          <a:chExt cx="0" cy="0"/>
+        </a:xfrm>
+      </p:grpSpPr>
+      <p:sp>
+        <p:nvSpPr>
+          <p:cNvPr id="2" name="Slide Image Placeholder 1"/>
+          <p:cNvSpPr>
+            <a:spLocks noGrp="1"/>
+          </p:cNvSpPr>
+          <p:nvPr>
+            <p:ph type="sldImg" idx="2"/>
+          </p:nvPr>
+        </p:nvSpPr>
+        <p:spPr/>
+      </p:sp>
+      <p:sp>
+        <p:nvSpPr>
+          <p:cNvPr id="3" name="Notes Placeholder 2"/>
+          <p:cNvSpPr>
+            <a:spLocks noGrp="1"/>
+          </p:cNvSpPr>
+          <p:nvPr>
+            <p:ph type="body" idx="3" sz="quarter"/>
+          </p:nvPr>
+        </p:nvSpPr>
+        <p:spPr/>
+        <p:txBody>
+          <a:bodyPr/>
+          <a:lstStyle/>
+          <a:p>
+            <a:r>
+              <a:t>Deliveries out, to customers · last 30 days: Deliveries 868; On time 93.0%; Late 60; Overdue now 1; In full 98.0%.</a:t>
+            </a:r>
+          </a:p>
+        </p:txBody>
+      </p:sp>
+      <p:sp>
+        <p:nvSpPr>
+          <p:cNvPr id="4" name="Slide Number Placeholder 3"/>
+          <p:cNvSpPr>
+            <a:spLocks noGrp="1"/>
+          </p:cNvSpPr>
+          <p:nvPr>
+            <p:ph type="sldNum" idx="5" sz="quarter"/>
+          </p:nvPr>
+        </p:nvSpPr>
+        <p:spPr/>
+      </p:sp>
+    </p:spTree>
+  </p:cSld>
+  <p:clrMapOvr>
+    <a:masterClrMapping/>
+  </p:clrMapOvr>
+</p:notes>
+</file>
+
+<file path=ppt/notesSlides/notesSlide3.xml><?xml version="1.0" encoding="utf-8"?>
+<p:notes xmlns:a="http://schemas.openxmlformats.org/drawingml/2006/main" xmlns:p="http://schemas.openxmlformats.org/presentationml/2006/main" xmlns:r="http://schemas.openxmlformats.org/officeDocument/2006/relationships">
+  <p:cSld>
+    <p:spTree>
+      <p:nvGrpSpPr>
+        <p:cNvPr id="1" name=""/>
+        <p:cNvGrpSpPr/>
+        <p:nvPr/>
+      </p:nvGrpSpPr>
+      <p:grpSpPr>
+        <a:xfrm>
+          <a:off x="0" y="0"/>
+          <a:ext cx="0" cy="0"/>
+          <a:chOff x="0" y="0"/>
+          <a:chExt cx="0" cy="0"/>
+        </a:xfrm>
+      </p:grpSpPr>
+      <p:sp>
+        <p:nvSpPr>
+          <p:cNvPr id="2" name="Slide Image Placeholder 1"/>
+          <p:cNvSpPr>
+            <a:spLocks noGrp="1"/>
+          </p:cNvSpPr>
+          <p:nvPr>
+            <p:ph type="sldImg" idx="2"/>
+          </p:nvPr>
+        </p:nvSpPr>
+        <p:spPr/>
+      </p:sp>
+      <p:sp>
+        <p:nvSpPr>
+          <p:cNvPr id="3" name="Notes Placeholder 2"/>
+          <p:cNvSpPr>
+            <a:spLocks noGrp="1"/>
+          </p:cNvSpPr>
+          <p:nvPr>
+            <p:ph type="body" idx="3" sz="quarter"/>
+          </p:nvPr>
+        </p:nvSpPr>
+        <p:spPr/>
+        <p:txBody>
+          <a:bodyPr/>
+          <a:lstStyle/>
+          <a:p>
+            <a:r>
+              <a:t>Deliveries out, to customers · map. Green 95%+ on time · amber 80-95% · brick under 80% or overdue · grey-blue on its way. Dot size = number of deliveries.</a:t>
+            </a:r>
+          </a:p>
+        </p:txBody>
+      </p:sp>
+      <p:sp>
+        <p:nvSpPr>
+          <p:cNvPr id="4" name="Slide Number Placeholder 3"/>
+          <p:cNvSpPr>
+            <a:spLocks noGrp="1"/>
+          </p:cNvSpPr>
+          <p:nvPr>
+            <p:ph type="sldNum" idx="5" sz="quarter"/>
+          </p:nvPr>
+        </p:nvSpPr>
+        <p:spPr/>
+      </p:sp>
+    </p:spTree>
+  </p:cSld>
+  <p:clrMapOvr>
+    <a:masterClrMapping/>
+  </p:clrMapOvr>
+</p:notes>
+</file>
+
+<file path=ppt/notesSlides/notesSlide4.xml><?xml version="1.0" encoding="utf-8"?>
+<p:notes xmlns:a="http://schemas.openxmlformats.org/drawingml/2006/main" xmlns:p="http://schemas.openxmlformats.org/presentationml/2006/main" xmlns:r="http://schemas.openxmlformats.org/officeDocument/2006/relationships">
+  <p:cSld>
+    <p:spTree>
+      <p:nvGrpSpPr>
+        <p:cNvPr id="1" name=""/>
+        <p:cNvGrpSpPr/>
+        <p:nvPr/>
+      </p:nvGrpSpPr>
+      <p:grpSpPr>
+        <a:xfrm>
+          <a:off x="0" y="0"/>
+          <a:ext cx="0" cy="0"/>
+          <a:chOff x="0" y="0"/>
+          <a:chExt cx="0" cy="0"/>
+        </a:xfrm>
+      </p:grpSpPr>
+      <p:sp>
+        <p:nvSpPr>
+          <p:cNvPr id="2" name="Slide Image Placeholder 1"/>
+          <p:cNvSpPr>
+            <a:spLocks noGrp="1"/>
+          </p:cNvSpPr>
+          <p:nvPr>
+            <p:ph type="sldImg" idx="2"/>
+          </p:nvPr>
+        </p:nvSpPr>
+        <p:spPr/>
+      </p:sp>
+      <p:sp>
+        <p:nvSpPr>
+          <p:cNvPr id="3" name="Notes Placeholder 2"/>
+          <p:cNvSpPr>
+            <a:spLocks noGrp="1"/>
+          </p:cNvSpPr>
+          <p:nvPr>
+            <p:ph type="body" idx="3" sz="quarter"/>
+          </p:nvPr>
+        </p:nvSpPr>
+        <p:spPr/>
+        <p:txBody>
+          <a:bodyPr/>
+          <a:lstStyle/>
+          <a:p>
+            <a:r>
+              <a:t>Deliveries out, to customers · where it's going wrong</a:t>
+            </a:r>
+          </a:p>
+        </p:txBody>
+      </p:sp>
+      <p:sp>
+        <p:nvSpPr>
+          <p:cNvPr id="4" name="Slide Number Placeholder 3"/>
+          <p:cNvSpPr>
+            <a:spLocks noGrp="1"/>
+          </p:cNvSpPr>
+          <p:nvPr>
+            <p:ph type="sldNum" idx="5" sz="quarter"/>
+          </p:nvPr>
+        </p:nvSpPr>
+        <p:spPr/>
+      </p:sp>
+    </p:spTree>
+  </p:cSld>
+  <p:clrMapOvr>
+    <a:masterClrMapping/>
+  </p:clrMapOvr>
+</p:notes>
+</file>
+
+<file path=ppt/notesSlides/notesSlide5.xml><?xml version="1.0" encoding="utf-8"?>
+<p:notes xmlns:a="http://schemas.openxmlformats.org/drawingml/2006/main" xmlns:p="http://schemas.openxmlformats.org/presentationml/2006/main" xmlns:r="http://schemas.openxmlformats.org/officeDocument/2006/relationships">
+  <p:cSld>
+    <p:spTree>
+      <p:nvGrpSpPr>
+        <p:cNvPr id="1" name=""/>
+        <p:cNvGrpSpPr/>
+        <p:nvPr/>
+      </p:nvGrpSpPr>
+      <p:grpSpPr>
+        <a:xfrm>
+          <a:off x="0" y="0"/>
+          <a:ext cx="0" cy="0"/>
+          <a:chOff x="0" y="0"/>
+          <a:chExt cx="0" cy="0"/>
+        </a:xfrm>
+      </p:grpSpPr>
+      <p:sp>
+        <p:nvSpPr>
+          <p:cNvPr id="2" name="Slide Image Placeholder 1"/>
+          <p:cNvSpPr>
+            <a:spLocks noGrp="1"/>
+          </p:cNvSpPr>
+          <p:nvPr>
+            <p:ph type="sldImg" idx="2"/>
+          </p:nvPr>
+        </p:nvSpPr>
+        <p:spPr/>
+      </p:sp>
+      <p:sp>
+        <p:nvSpPr>
+          <p:cNvPr id="3" name="Notes Placeholder 2"/>
+          <p:cNvSpPr>
+            <a:spLocks noGrp="1"/>
+          </p:cNvSpPr>
+          <p:nvPr>
+            <p:ph type="body" idx="3" sz="quarter"/>
+          </p:nvPr>
+        </p:nvSpPr>
+        <p:spPr/>
+        <p:txBody>
+          <a:bodyPr/>
+          <a:lstStyle/>
+          <a:p>
+            <a:r>
+              <a:t>Deliveries in, from suppliers · last 30 days: Deliveries 128; On time 91.9%; Late 10; Overdue now 2; In full 90.3%.</a:t>
+            </a:r>
+          </a:p>
+        </p:txBody>
+      </p:sp>
+      <p:sp>
+        <p:nvSpPr>
+          <p:cNvPr id="4" name="Slide Number Placeholder 3"/>
+          <p:cNvSpPr>
+            <a:spLocks noGrp="1"/>
+          </p:cNvSpPr>
+          <p:nvPr>
+            <p:ph type="sldNum" idx="5" sz="quarter"/>
+          </p:nvPr>
+        </p:nvSpPr>
+        <p:spPr/>
+      </p:sp>
+    </p:spTree>
+  </p:cSld>
+  <p:clrMapOvr>
+    <a:masterClrMapping/>
+  </p:clrMapOvr>
+</p:notes>
+</file>
+
+<file path=ppt/notesSlides/notesSlide6.xml><?xml version="1.0" encoding="utf-8"?>
+<p:notes xmlns:a="http://schemas.openxmlformats.org/drawingml/2006/main" xmlns:p="http://schemas.openxmlformats.org/presentationml/2006/main" xmlns:r="http://schemas.openxmlformats.org/officeDocument/2006/relationships">
+  <p:cSld>
+    <p:spTree>
+      <p:nvGrpSpPr>
+        <p:cNvPr id="1" name=""/>
+        <p:cNvGrpSpPr/>
+        <p:nvPr/>
+      </p:nvGrpSpPr>
+      <p:grpSpPr>
+        <a:xfrm>
+          <a:off x="0" y="0"/>
+          <a:ext cx="0" cy="0"/>
+          <a:chOff x="0" y="0"/>
+          <a:chExt cx="0" cy="0"/>
+        </a:xfrm>
+      </p:grpSpPr>
+      <p:sp>
+        <p:nvSpPr>
+          <p:cNvPr id="2" name="Slide Image Placeholder 1"/>
+          <p:cNvSpPr>
+            <a:spLocks noGrp="1"/>
+          </p:cNvSpPr>
+          <p:nvPr>
+            <p:ph type="sldImg" idx="2"/>
+          </p:nvPr>
+        </p:nvSpPr>
+        <p:spPr/>
+      </p:sp>
+      <p:sp>
+        <p:nvSpPr>
+          <p:cNvPr id="3" name="Notes Placeholder 2"/>
+          <p:cNvSpPr>
+            <a:spLocks noGrp="1"/>
+          </p:cNvSpPr>
+          <p:nvPr>
+            <p:ph type="body" idx="3" sz="quarter"/>
+          </p:nvPr>
+        </p:nvSpPr>
+        <p:spPr/>
+        <p:txBody>
+          <a:bodyPr/>
+          <a:lstStyle/>
+          <a:p>
+            <a:r>
+              <a:t>Deliveries in, from suppliers · map. Green 95%+ on time · amber 80-95% · brick under 80% or overdue · grey-blue on its way. Dot size = number of deliveries.</a:t>
+            </a:r>
+          </a:p>
+        </p:txBody>
+      </p:sp>
+      <p:sp>
+        <p:nvSpPr>
+          <p:cNvPr id="4" name="Slide Number Placeholder 3"/>
+          <p:cNvSpPr>
+            <a:spLocks noGrp="1"/>
+          </p:cNvSpPr>
+          <p:nvPr>
+            <p:ph type="sldNum" idx="5" sz="quarter"/>
+          </p:nvPr>
+        </p:nvSpPr>
+        <p:spPr/>
+      </p:sp>
+    </p:spTree>
+  </p:cSld>
+  <p:clrMapOvr>
+    <a:masterClrMapping/>
+  </p:clrMapOvr>
+</p:notes>
+</file>
+
+<file path=ppt/notesSlides/notesSlide7.xml><?xml version="1.0" encoding="utf-8"?>
+<p:notes xmlns:a="http://schemas.openxmlformats.org/drawingml/2006/main" xmlns:p="http://schemas.openxmlformats.org/presentationml/2006/main" xmlns:r="http://schemas.openxmlformats.org/officeDocument/2006/relationships">
+  <p:cSld>
+    <p:spTree>
+      <p:nvGrpSpPr>
+        <p:cNvPr id="1" name=""/>
+        <p:cNvGrpSpPr/>
+        <p:nvPr/>
+      </p:nvGrpSpPr>
+      <p:grpSpPr>
+        <a:xfrm>
+          <a:off x="0" y="0"/>
+          <a:ext cx="0" cy="0"/>
+          <a:chOff x="0" y="0"/>
+          <a:chExt cx="0" cy="0"/>
+        </a:xfrm>
+      </p:grpSpPr>
+      <p:sp>
+        <p:nvSpPr>
+          <p:cNvPr id="2" name="Slide Image Placeholder 1"/>
+          <p:cNvSpPr>
+            <a:spLocks noGrp="1"/>
+          </p:cNvSpPr>
+          <p:nvPr>
+            <p:ph type="sldImg" idx="2"/>
+          </p:nvPr>
+        </p:nvSpPr>
+        <p:spPr/>
+      </p:sp>
+      <p:sp>
+        <p:nvSpPr>
+          <p:cNvPr id="3" name="Notes Placeholder 2"/>
+          <p:cNvSpPr>
+            <a:spLocks noGrp="1"/>
+          </p:cNvSpPr>
+          <p:nvPr>
+            <p:ph type="body" idx="3" sz="quarter"/>
+          </p:nvPr>
+        </p:nvSpPr>
+        <p:spPr/>
+        <p:txBody>
+          <a:bodyPr/>
+          <a:lstStyle/>
+          <a:p>
+            <a:r>
+              <a:t>Deliveries in, from suppliers · where it's going wrong</a:t>
+            </a:r>
+          </a:p>
+        </p:txBody>
+      </p:sp>
+      <p:sp>
+        <p:nvSpPr>
+          <p:cNvPr id="4" name="Slide Number Placeholder 3"/>
+          <p:cNvSpPr>
+            <a:spLocks noGrp="1"/>
+          </p:cNvSpPr>
+          <p:nvPr>
+            <p:ph type="sldNum" idx="5" sz="quarter"/>
+          </p:nvPr>
+        </p:nvSpPr>
+        <p:spPr/>
+      </p:sp>
+    </p:spTree>
+  </p:cSld>
+  <p:clrMapOvr>
+    <a:masterClrMapping/>
+  </p:clrMapOvr>
+</p:notes>
 </file>
 
 <file path=ppt/slideLayouts/slideLayout1.xml><?xml version="1.0" encoding="utf-8"?>
@@ -3096,7 +3936,44 @@
       <p:grpSpPr/>
       <p:sp>
         <p:nvSpPr>
-          <p:cNvPr id="2" name="Rectangle 1"/>
+          <p:cNvPr id="2" name="Title 1"/>
+          <p:cNvSpPr>
+            <a:spLocks noGrp="1"/>
+          </p:cNvSpPr>
+          <p:nvPr>
+            <p:ph type="ctrTitle"/>
+          </p:nvPr>
+        </p:nvSpPr>
+        <p:spPr>
+          <a:xfrm>
+            <a:off x="457200" y="1965960"/>
+            <a:ext cx="11277295" cy="1097280"/>
+          </a:xfrm>
+        </p:spPr>
+        <p:txBody>
+          <a:bodyPr wrap="square"/>
+          <a:lstStyle/>
+          <a:p>
+            <a:pPr algn="l">
+              <a:defRPr>
+                <a:latin typeface="Roboto"/>
+              </a:defRPr>
+            </a:pPr>
+            <a:r>
+              <a:rPr sz="3400" b="1">
+                <a:solidFill>
+                  <a:srgbClr val="25342A"/>
+                </a:solidFill>
+                <a:latin typeface="Roboto"/>
+              </a:rPr>
+              <a:t>Deliveries in and out</a:t>
+            </a:r>
+          </a:p>
+        </p:txBody>
+      </p:sp>
+      <p:sp>
+        <p:nvSpPr>
+          <p:cNvPr id="3" name="Rectangle 2"/>
           <p:cNvSpPr/>
           <p:nvPr/>
         </p:nvSpPr>
@@ -3152,53 +4029,14 @@
       </p:sp>
       <p:sp>
         <p:nvSpPr>
-          <p:cNvPr id="3" name="TextBox 2"/>
-          <p:cNvSpPr txBox="1"/>
-          <p:nvPr/>
-        </p:nvSpPr>
-        <p:spPr>
-          <a:xfrm>
-            <a:off x="1234440" y="658368"/>
-            <a:ext cx="5486400" cy="457200"/>
-          </a:xfrm>
-          <a:prstGeom prst="rect">
-            <a:avLst/>
-          </a:prstGeom>
-          <a:noFill/>
-        </p:spPr>
-        <p:txBody>
-          <a:bodyPr wrap="square">
-            <a:spAutoFit/>
-          </a:bodyPr>
-          <a:lstStyle/>
-          <a:p>
-            <a:pPr>
-              <a:defRPr>
-                <a:latin typeface="Roboto"/>
-              </a:defRPr>
-            </a:pPr>
-            <a:r>
-              <a:rPr sz="1800" b="1">
-                <a:solidFill>
-                  <a:srgbClr val="25342A"/>
-                </a:solidFill>
-                <a:latin typeface="Roboto"/>
-              </a:rPr>
-              <a:t>The Fourth Sheet</a:t>
-            </a:r>
-          </a:p>
-        </p:txBody>
-      </p:sp>
-      <p:sp>
-        <p:nvSpPr>
           <p:cNvPr id="4" name="TextBox 3"/>
           <p:cNvSpPr txBox="1"/>
           <p:nvPr/>
         </p:nvSpPr>
         <p:spPr>
           <a:xfrm>
-            <a:off x="457200" y="1554480"/>
-            <a:ext cx="10972800" cy="365760"/>
+            <a:off x="1234440" y="658368"/>
+            <a:ext cx="5486400" cy="457200"/>
           </a:xfrm>
           <a:prstGeom prst="rect">
             <a:avLst/>
@@ -3206,7 +4044,7 @@
           <a:noFill/>
         </p:spPr>
         <p:txBody>
-          <a:bodyPr wrap="square">
+          <a:bodyPr wrap="square" lIns="45720" rIns="45720">
             <a:spAutoFit/>
           </a:bodyPr>
           <a:lstStyle/>
@@ -3217,13 +4055,13 @@
               </a:defRPr>
             </a:pPr>
             <a:r>
-              <a:rPr sz="1100" b="1">
-                <a:solidFill>
-                  <a:srgbClr val="8A7A52"/>
+              <a:rPr sz="1800" b="1">
+                <a:solidFill>
+                  <a:srgbClr val="25342A"/>
                 </a:solidFill>
                 <a:latin typeface="Roboto"/>
               </a:rPr>
-              <a:t>SAMPLE DATA · invented figures for demonstration</a:t>
+              <a:t>The Fourth Sheet</a:t>
             </a:r>
           </a:p>
         </p:txBody>
@@ -3236,8 +4074,8 @@
         </p:nvSpPr>
         <p:spPr>
           <a:xfrm>
-            <a:off x="457200" y="2011680"/>
-            <a:ext cx="11247120" cy="1097280"/>
+            <a:off x="457200" y="1554480"/>
+            <a:ext cx="10972800" cy="365760"/>
           </a:xfrm>
           <a:prstGeom prst="rect">
             <a:avLst/>
@@ -3245,7 +4083,7 @@
           <a:noFill/>
         </p:spPr>
         <p:txBody>
-          <a:bodyPr wrap="square">
+          <a:bodyPr wrap="square" lIns="45720" rIns="45720">
             <a:spAutoFit/>
           </a:bodyPr>
           <a:lstStyle/>
@@ -3256,13 +4094,13 @@
               </a:defRPr>
             </a:pPr>
             <a:r>
-              <a:rPr sz="3400" b="1">
-                <a:solidFill>
-                  <a:srgbClr val="25342A"/>
+              <a:rPr sz="1100" b="1">
+                <a:solidFill>
+                  <a:srgbClr val="8A7A52"/>
                 </a:solidFill>
                 <a:latin typeface="Roboto"/>
               </a:rPr>
-              <a:t>Deliveries in and out</a:t>
+              <a:t>SAMPLE DATA · invented figures for demonstration</a:t>
             </a:r>
           </a:p>
         </p:txBody>
@@ -3276,7 +4114,7 @@
         <p:spPr>
           <a:xfrm>
             <a:off x="457200" y="3154680"/>
-            <a:ext cx="11247120" cy="457200"/>
+            <a:ext cx="11277295" cy="457200"/>
           </a:xfrm>
           <a:prstGeom prst="rect">
             <a:avLst/>
@@ -3284,7 +4122,7 @@
           <a:noFill/>
         </p:spPr>
         <p:txBody>
-          <a:bodyPr wrap="square">
+          <a:bodyPr wrap="square" lIns="45720" rIns="45720">
             <a:spAutoFit/>
           </a:bodyPr>
           <a:lstStyle/>
@@ -3315,7 +4153,7 @@
         <p:spPr>
           <a:xfrm>
             <a:off x="457200" y="3703320"/>
-            <a:ext cx="11247120" cy="1097280"/>
+            <a:ext cx="11277295" cy="313690"/>
           </a:xfrm>
           <a:prstGeom prst="rect">
             <a:avLst/>
@@ -3323,7 +4161,7 @@
           <a:noFill/>
         </p:spPr>
         <p:txBody>
-          <a:bodyPr wrap="square">
+          <a:bodyPr wrap="square" lIns="45720" rIns="45720">
             <a:spAutoFit/>
           </a:bodyPr>
           <a:lstStyle/>
@@ -3353,8 +4191,8 @@
         </p:nvSpPr>
         <p:spPr>
           <a:xfrm>
-            <a:off x="457200" y="4937760"/>
-            <a:ext cx="11247120" cy="1097280"/>
+            <a:off x="457200" y="4108450"/>
+            <a:ext cx="11277295" cy="1097280"/>
           </a:xfrm>
           <a:prstGeom prst="rect">
             <a:avLst/>
@@ -3362,7 +4200,7 @@
           <a:noFill/>
         </p:spPr>
         <p:txBody>
-          <a:bodyPr wrap="square">
+          <a:bodyPr wrap="square" lIns="45720" rIns="45720">
             <a:spAutoFit/>
           </a:bodyPr>
           <a:lstStyle/>
@@ -3441,7 +4279,7 @@
         <p:spPr>
           <a:xfrm>
             <a:off x="457200" y="6492240"/>
-            <a:ext cx="3657600" cy="274320"/>
+            <a:ext cx="2926080" cy="274320"/>
           </a:xfrm>
           <a:prstGeom prst="rect">
             <a:avLst/>
@@ -3449,7 +4287,7 @@
           <a:noFill/>
         </p:spPr>
         <p:txBody>
-          <a:bodyPr wrap="square">
+          <a:bodyPr wrap="square" lIns="45720" rIns="45720">
             <a:spAutoFit/>
           </a:bodyPr>
           <a:lstStyle/>
@@ -3479,8 +4317,8 @@
         </p:nvSpPr>
         <p:spPr>
           <a:xfrm>
-            <a:off x="4297680" y="6492240"/>
-            <a:ext cx="3657600" cy="274320"/>
+            <a:off x="3108960" y="6492240"/>
+            <a:ext cx="5943600" cy="274320"/>
           </a:xfrm>
           <a:prstGeom prst="rect">
             <a:avLst/>
@@ -3488,7 +4326,7 @@
           <a:noFill/>
         </p:spPr>
         <p:txBody>
-          <a:bodyPr wrap="square">
+          <a:bodyPr wrap="square" lIns="45720" rIns="45720">
             <a:spAutoFit/>
           </a:bodyPr>
           <a:lstStyle/>
@@ -3505,7 +4343,7 @@
                 </a:solidFill>
                 <a:latin typeface="Roboto"/>
               </a:rPr>
-              <a:t>Data retrieved 2pm, Tue 6 Oct 2026 · Sample data</a:t>
+              <a:t>Data retrieved 2pm, Tue 6 Oct 2026 · Generated 8 Oct 2026, 9:42am · Sample data · Made with Python (python-pptx)</a:t>
             </a:r>
           </a:p>
         </p:txBody>
@@ -3527,7 +4365,7 @@
           <a:noFill/>
         </p:spPr>
         <p:txBody>
-          <a:bodyPr wrap="square">
+          <a:bodyPr wrap="square" lIns="45720" rIns="45720">
             <a:spAutoFit/>
           </a:bodyPr>
           <a:lstStyle/>
@@ -3569,7 +4407,44 @@
       <p:grpSpPr/>
       <p:sp>
         <p:nvSpPr>
-          <p:cNvPr id="2" name="Rectangle 1"/>
+          <p:cNvPr id="2" name="Title 1"/>
+          <p:cNvSpPr>
+            <a:spLocks noGrp="1"/>
+          </p:cNvSpPr>
+          <p:nvPr>
+            <p:ph type="title"/>
+          </p:nvPr>
+        </p:nvSpPr>
+        <p:spPr>
+          <a:xfrm>
+            <a:off x="457200" y="384048"/>
+            <a:ext cx="11277295" cy="475488"/>
+          </a:xfrm>
+        </p:spPr>
+        <p:txBody>
+          <a:bodyPr wrap="square" lIns="45720" rIns="45720" tIns="0" bIns="0" anchor="t"/>
+          <a:lstStyle/>
+          <a:p>
+            <a:pPr algn="l">
+              <a:defRPr>
+                <a:latin typeface="Roboto"/>
+              </a:defRPr>
+            </a:pPr>
+            <a:r>
+              <a:rPr sz="2400" b="1">
+                <a:solidFill>
+                  <a:srgbClr val="25342A"/>
+                </a:solidFill>
+                <a:latin typeface="Roboto"/>
+              </a:rPr>
+              <a:t>Deliveries out, to customers · last 30 days</a:t>
+            </a:r>
+          </a:p>
+        </p:txBody>
+      </p:sp>
+      <p:sp>
+        <p:nvSpPr>
+          <p:cNvPr id="3" name="Rectangle 2"/>
           <p:cNvSpPr/>
           <p:nvPr/>
         </p:nvSpPr>
@@ -3616,53 +4491,14 @@
       </p:sp>
       <p:sp>
         <p:nvSpPr>
-          <p:cNvPr id="3" name="TextBox 2"/>
-          <p:cNvSpPr txBox="1"/>
-          <p:nvPr/>
-        </p:nvSpPr>
-        <p:spPr>
-          <a:xfrm>
-            <a:off x="457200" y="164592"/>
-            <a:ext cx="7315200" cy="274320"/>
-          </a:xfrm>
-          <a:prstGeom prst="rect">
-            <a:avLst/>
-          </a:prstGeom>
-          <a:noFill/>
-        </p:spPr>
-        <p:txBody>
-          <a:bodyPr wrap="square">
-            <a:spAutoFit/>
-          </a:bodyPr>
-          <a:lstStyle/>
-          <a:p>
-            <a:pPr>
-              <a:defRPr>
-                <a:latin typeface="Roboto"/>
-              </a:defRPr>
-            </a:pPr>
-            <a:r>
-              <a:rPr sz="1000" b="0">
-                <a:solidFill>
-                  <a:srgbClr val="5F6F63"/>
-                </a:solidFill>
-                <a:latin typeface="Roboto"/>
-              </a:rPr>
-              <a:t>Sample Distribution Pty Ltd · Deliveries in and out</a:t>
-            </a:r>
-          </a:p>
-        </p:txBody>
-      </p:sp>
-      <p:sp>
-        <p:nvSpPr>
           <p:cNvPr id="4" name="TextBox 3"/>
           <p:cNvSpPr txBox="1"/>
           <p:nvPr/>
         </p:nvSpPr>
         <p:spPr>
           <a:xfrm>
-            <a:off x="457200" y="411480"/>
-            <a:ext cx="11247120" cy="548640"/>
+            <a:off x="457200" y="146304"/>
+            <a:ext cx="8229600" cy="256032"/>
           </a:xfrm>
           <a:prstGeom prst="rect">
             <a:avLst/>
@@ -3670,7 +4506,7 @@
           <a:noFill/>
         </p:spPr>
         <p:txBody>
-          <a:bodyPr wrap="square">
+          <a:bodyPr wrap="square" lIns="45720" rIns="45720">
             <a:spAutoFit/>
           </a:bodyPr>
           <a:lstStyle/>
@@ -3681,13 +4517,13 @@
               </a:defRPr>
             </a:pPr>
             <a:r>
-              <a:rPr sz="2400" b="1">
-                <a:solidFill>
-                  <a:srgbClr val="25342A"/>
+              <a:rPr sz="1000" b="0">
+                <a:solidFill>
+                  <a:srgbClr val="5F6F63"/>
                 </a:solidFill>
                 <a:latin typeface="Roboto"/>
               </a:rPr>
-              <a:t>Deliveries out, to customers · last 30 days</a:t>
+              <a:t>Sample Distribution Pty Ltd · Deliveries in and out</a:t>
             </a:r>
           </a:p>
         </p:txBody>
@@ -3700,8 +4536,8 @@
         </p:nvSpPr>
         <p:spPr>
           <a:xfrm>
-            <a:off x="457200" y="1645920"/>
-            <a:ext cx="2036003" cy="2011680"/>
+            <a:off x="457200" y="1188720"/>
+            <a:ext cx="2072579" cy="1737360"/>
           </a:xfrm>
           <a:prstGeom prst="rect">
             <a:avLst/>
@@ -3749,8 +4585,8 @@
         </p:nvSpPr>
         <p:spPr>
           <a:xfrm>
-            <a:off x="640080" y="1783080"/>
-            <a:ext cx="1670243" cy="457200"/>
+            <a:off x="594360" y="1261872"/>
+            <a:ext cx="1798259" cy="384048"/>
           </a:xfrm>
           <a:prstGeom prst="rect">
             <a:avLst/>
@@ -3758,7 +4594,7 @@
           <a:noFill/>
         </p:spPr>
         <p:txBody>
-          <a:bodyPr wrap="square">
+          <a:bodyPr wrap="square" lIns="45720" rIns="45720">
             <a:spAutoFit/>
           </a:bodyPr>
           <a:lstStyle/>
@@ -3769,7 +4605,7 @@
               </a:defRPr>
             </a:pPr>
             <a:r>
-              <a:rPr sz="1200" b="0">
+              <a:rPr sz="1100" b="0">
                 <a:solidFill>
                   <a:srgbClr val="5F6F63"/>
                 </a:solidFill>
@@ -3788,8 +4624,8 @@
         </p:nvSpPr>
         <p:spPr>
           <a:xfrm>
-            <a:off x="640080" y="2240280"/>
-            <a:ext cx="1670243" cy="731520"/>
+            <a:off x="594360" y="1627632"/>
+            <a:ext cx="1798259" cy="502920"/>
           </a:xfrm>
           <a:prstGeom prst="rect">
             <a:avLst/>
@@ -3797,7 +4633,7 @@
           <a:noFill/>
         </p:spPr>
         <p:txBody>
-          <a:bodyPr wrap="square">
+          <a:bodyPr wrap="square" lIns="45720" rIns="45720">
             <a:spAutoFit/>
           </a:bodyPr>
           <a:lstStyle/>
@@ -3808,7 +4644,7 @@
               </a:defRPr>
             </a:pPr>
             <a:r>
-              <a:rPr sz="3000" b="1">
+              <a:rPr sz="2600" b="1">
                 <a:solidFill>
                   <a:srgbClr val="2F7A5D"/>
                 </a:solidFill>
@@ -3827,8 +4663,8 @@
         </p:nvSpPr>
         <p:spPr>
           <a:xfrm>
-            <a:off x="640080" y="3017520"/>
-            <a:ext cx="1670243" cy="548640"/>
+            <a:off x="594360" y="2542032"/>
+            <a:ext cx="1798259" cy="329184"/>
           </a:xfrm>
           <a:prstGeom prst="rect">
             <a:avLst/>
@@ -3836,7 +4672,7 @@
           <a:noFill/>
         </p:spPr>
         <p:txBody>
-          <a:bodyPr wrap="square">
+          <a:bodyPr wrap="square" lIns="45720" rIns="45720">
             <a:spAutoFit/>
           </a:bodyPr>
           <a:lstStyle/>
@@ -3847,7 +4683,7 @@
               </a:defRPr>
             </a:pPr>
             <a:r>
-              <a:rPr sz="1100" b="0">
+              <a:rPr sz="1000" b="0">
                 <a:solidFill>
                   <a:srgbClr val="5F6F63"/>
                 </a:solidFill>
@@ -3866,8 +4702,8 @@
         </p:nvSpPr>
         <p:spPr>
           <a:xfrm>
-            <a:off x="2767523" y="1645920"/>
-            <a:ext cx="2036003" cy="2011680"/>
+            <a:off x="2758379" y="1188720"/>
+            <a:ext cx="2072579" cy="1737360"/>
           </a:xfrm>
           <a:prstGeom prst="rect">
             <a:avLst/>
@@ -3915,8 +4751,8 @@
         </p:nvSpPr>
         <p:spPr>
           <a:xfrm>
-            <a:off x="2950403" y="1783080"/>
-            <a:ext cx="1670243" cy="457200"/>
+            <a:off x="2895539" y="1261872"/>
+            <a:ext cx="1798259" cy="384048"/>
           </a:xfrm>
           <a:prstGeom prst="rect">
             <a:avLst/>
@@ -3924,7 +4760,7 @@
           <a:noFill/>
         </p:spPr>
         <p:txBody>
-          <a:bodyPr wrap="square">
+          <a:bodyPr wrap="square" lIns="45720" rIns="45720">
             <a:spAutoFit/>
           </a:bodyPr>
           <a:lstStyle/>
@@ -3935,7 +4771,7 @@
               </a:defRPr>
             </a:pPr>
             <a:r>
-              <a:rPr sz="1200" b="0">
+              <a:rPr sz="1100" b="0">
                 <a:solidFill>
                   <a:srgbClr val="5F6F63"/>
                 </a:solidFill>
@@ -3954,8 +4790,8 @@
         </p:nvSpPr>
         <p:spPr>
           <a:xfrm>
-            <a:off x="2950403" y="2240280"/>
-            <a:ext cx="1670243" cy="731520"/>
+            <a:off x="2895539" y="1627632"/>
+            <a:ext cx="1798259" cy="502920"/>
           </a:xfrm>
           <a:prstGeom prst="rect">
             <a:avLst/>
@@ -3963,7 +4799,7 @@
           <a:noFill/>
         </p:spPr>
         <p:txBody>
-          <a:bodyPr wrap="square">
+          <a:bodyPr wrap="square" lIns="45720" rIns="45720">
             <a:spAutoFit/>
           </a:bodyPr>
           <a:lstStyle/>
@@ -3974,7 +4810,7 @@
               </a:defRPr>
             </a:pPr>
             <a:r>
-              <a:rPr sz="3000" b="1">
+              <a:rPr sz="2600" b="1">
                 <a:solidFill>
                   <a:srgbClr val="2F7A5D"/>
                 </a:solidFill>
@@ -3993,8 +4829,8 @@
         </p:nvSpPr>
         <p:spPr>
           <a:xfrm>
-            <a:off x="2950403" y="3017520"/>
-            <a:ext cx="1670243" cy="548640"/>
+            <a:off x="2895539" y="2542032"/>
+            <a:ext cx="1798259" cy="329184"/>
           </a:xfrm>
           <a:prstGeom prst="rect">
             <a:avLst/>
@@ -4002,7 +4838,7 @@
           <a:noFill/>
         </p:spPr>
         <p:txBody>
-          <a:bodyPr wrap="square">
+          <a:bodyPr wrap="square" lIns="45720" rIns="45720">
             <a:spAutoFit/>
           </a:bodyPr>
           <a:lstStyle/>
@@ -4013,7 +4849,7 @@
               </a:defRPr>
             </a:pPr>
             <a:r>
-              <a:rPr sz="1100" b="0">
+              <a:rPr sz="1000" b="0">
                 <a:solidFill>
                   <a:srgbClr val="5F6F63"/>
                 </a:solidFill>
@@ -4032,8 +4868,8 @@
         </p:nvSpPr>
         <p:spPr>
           <a:xfrm>
-            <a:off x="5077846" y="1645920"/>
-            <a:ext cx="2036003" cy="2011680"/>
+            <a:off x="5059558" y="1188720"/>
+            <a:ext cx="2072579" cy="1737360"/>
           </a:xfrm>
           <a:prstGeom prst="rect">
             <a:avLst/>
@@ -4081,8 +4917,8 @@
         </p:nvSpPr>
         <p:spPr>
           <a:xfrm>
-            <a:off x="5260726" y="1783080"/>
-            <a:ext cx="1670243" cy="457200"/>
+            <a:off x="5196718" y="1261872"/>
+            <a:ext cx="1798259" cy="384048"/>
           </a:xfrm>
           <a:prstGeom prst="rect">
             <a:avLst/>
@@ -4090,7 +4926,7 @@
           <a:noFill/>
         </p:spPr>
         <p:txBody>
-          <a:bodyPr wrap="square">
+          <a:bodyPr wrap="square" lIns="45720" rIns="45720">
             <a:spAutoFit/>
           </a:bodyPr>
           <a:lstStyle/>
@@ -4101,7 +4937,7 @@
               </a:defRPr>
             </a:pPr>
             <a:r>
-              <a:rPr sz="1200" b="0">
+              <a:rPr sz="1100" b="0">
                 <a:solidFill>
                   <a:srgbClr val="5F6F63"/>
                 </a:solidFill>
@@ -4120,8 +4956,8 @@
         </p:nvSpPr>
         <p:spPr>
           <a:xfrm>
-            <a:off x="5260726" y="2240280"/>
-            <a:ext cx="1670243" cy="731520"/>
+            <a:off x="5196718" y="1627632"/>
+            <a:ext cx="1798259" cy="502920"/>
           </a:xfrm>
           <a:prstGeom prst="rect">
             <a:avLst/>
@@ -4129,7 +4965,7 @@
           <a:noFill/>
         </p:spPr>
         <p:txBody>
-          <a:bodyPr wrap="square">
+          <a:bodyPr wrap="square" lIns="45720" rIns="45720">
             <a:spAutoFit/>
           </a:bodyPr>
           <a:lstStyle/>
@@ -4140,7 +4976,7 @@
               </a:defRPr>
             </a:pPr>
             <a:r>
-              <a:rPr sz="3000" b="1">
+              <a:rPr sz="2600" b="1">
                 <a:solidFill>
                   <a:srgbClr val="2F7A5D"/>
                 </a:solidFill>
@@ -4159,8 +4995,8 @@
         </p:nvSpPr>
         <p:spPr>
           <a:xfrm>
-            <a:off x="5260726" y="3017520"/>
-            <a:ext cx="1670243" cy="548640"/>
+            <a:off x="5196718" y="2542032"/>
+            <a:ext cx="1798259" cy="329184"/>
           </a:xfrm>
           <a:prstGeom prst="rect">
             <a:avLst/>
@@ -4168,7 +5004,7 @@
           <a:noFill/>
         </p:spPr>
         <p:txBody>
-          <a:bodyPr wrap="square">
+          <a:bodyPr wrap="square" lIns="45720" rIns="45720">
             <a:spAutoFit/>
           </a:bodyPr>
           <a:lstStyle/>
@@ -4179,7 +5015,7 @@
               </a:defRPr>
             </a:pPr>
             <a:r>
-              <a:rPr sz="1100" b="0">
+              <a:rPr sz="1000" b="0">
                 <a:solidFill>
                   <a:srgbClr val="5F6F63"/>
                 </a:solidFill>
@@ -4198,8 +5034,8 @@
         </p:nvSpPr>
         <p:spPr>
           <a:xfrm>
-            <a:off x="7388169" y="1645920"/>
-            <a:ext cx="2036003" cy="2011680"/>
+            <a:off x="7360737" y="1188720"/>
+            <a:ext cx="2072579" cy="1737360"/>
           </a:xfrm>
           <a:prstGeom prst="rect">
             <a:avLst/>
@@ -4247,8 +5083,8 @@
         </p:nvSpPr>
         <p:spPr>
           <a:xfrm>
-            <a:off x="7571049" y="1783080"/>
-            <a:ext cx="1670243" cy="457200"/>
+            <a:off x="7497897" y="1261872"/>
+            <a:ext cx="1798259" cy="384048"/>
           </a:xfrm>
           <a:prstGeom prst="rect">
             <a:avLst/>
@@ -4256,7 +5092,7 @@
           <a:noFill/>
         </p:spPr>
         <p:txBody>
-          <a:bodyPr wrap="square">
+          <a:bodyPr wrap="square" lIns="45720" rIns="45720">
             <a:spAutoFit/>
           </a:bodyPr>
           <a:lstStyle/>
@@ -4267,7 +5103,7 @@
               </a:defRPr>
             </a:pPr>
             <a:r>
-              <a:rPr sz="1200" b="0">
+              <a:rPr sz="1100" b="0">
                 <a:solidFill>
                   <a:srgbClr val="5F6F63"/>
                 </a:solidFill>
@@ -4286,8 +5122,8 @@
         </p:nvSpPr>
         <p:spPr>
           <a:xfrm>
-            <a:off x="7571049" y="2240280"/>
-            <a:ext cx="1670243" cy="731520"/>
+            <a:off x="7497897" y="1627632"/>
+            <a:ext cx="1798259" cy="502920"/>
           </a:xfrm>
           <a:prstGeom prst="rect">
             <a:avLst/>
@@ -4295,7 +5131,7 @@
           <a:noFill/>
         </p:spPr>
         <p:txBody>
-          <a:bodyPr wrap="square">
+          <a:bodyPr wrap="square" lIns="45720" rIns="45720">
             <a:spAutoFit/>
           </a:bodyPr>
           <a:lstStyle/>
@@ -4306,7 +5142,7 @@
               </a:defRPr>
             </a:pPr>
             <a:r>
-              <a:rPr sz="3000" b="1">
+              <a:rPr sz="2600" b="1">
                 <a:solidFill>
                   <a:srgbClr val="2F7A5D"/>
                 </a:solidFill>
@@ -4325,8 +5161,8 @@
         </p:nvSpPr>
         <p:spPr>
           <a:xfrm>
-            <a:off x="7571049" y="3017520"/>
-            <a:ext cx="1670243" cy="548640"/>
+            <a:off x="7497897" y="2542032"/>
+            <a:ext cx="1798259" cy="329184"/>
           </a:xfrm>
           <a:prstGeom prst="rect">
             <a:avLst/>
@@ -4334,7 +5170,7 @@
           <a:noFill/>
         </p:spPr>
         <p:txBody>
-          <a:bodyPr wrap="square">
+          <a:bodyPr wrap="square" lIns="45720" rIns="45720">
             <a:spAutoFit/>
           </a:bodyPr>
           <a:lstStyle/>
@@ -4345,7 +5181,7 @@
               </a:defRPr>
             </a:pPr>
             <a:r>
-              <a:rPr sz="1100" b="0">
+              <a:rPr sz="1000" b="0">
                 <a:solidFill>
                   <a:srgbClr val="5F6F63"/>
                 </a:solidFill>
@@ -4364,8 +5200,8 @@
         </p:nvSpPr>
         <p:spPr>
           <a:xfrm>
-            <a:off x="9698492" y="1645920"/>
-            <a:ext cx="2036003" cy="2011680"/>
+            <a:off x="9661916" y="1188720"/>
+            <a:ext cx="2072579" cy="1737360"/>
           </a:xfrm>
           <a:prstGeom prst="rect">
             <a:avLst/>
@@ -4413,8 +5249,8 @@
         </p:nvSpPr>
         <p:spPr>
           <a:xfrm>
-            <a:off x="9881372" y="1783080"/>
-            <a:ext cx="1670243" cy="457200"/>
+            <a:off x="9799076" y="1261872"/>
+            <a:ext cx="1798259" cy="384048"/>
           </a:xfrm>
           <a:prstGeom prst="rect">
             <a:avLst/>
@@ -4422,7 +5258,7 @@
           <a:noFill/>
         </p:spPr>
         <p:txBody>
-          <a:bodyPr wrap="square">
+          <a:bodyPr wrap="square" lIns="45720" rIns="45720">
             <a:spAutoFit/>
           </a:bodyPr>
           <a:lstStyle/>
@@ -4433,7 +5269,7 @@
               </a:defRPr>
             </a:pPr>
             <a:r>
-              <a:rPr sz="1200" b="0">
+              <a:rPr sz="1100" b="0">
                 <a:solidFill>
                   <a:srgbClr val="5F6F63"/>
                 </a:solidFill>
@@ -4452,8 +5288,8 @@
         </p:nvSpPr>
         <p:spPr>
           <a:xfrm>
-            <a:off x="9881372" y="2240280"/>
-            <a:ext cx="1670243" cy="731520"/>
+            <a:off x="9799076" y="1627632"/>
+            <a:ext cx="1798259" cy="502920"/>
           </a:xfrm>
           <a:prstGeom prst="rect">
             <a:avLst/>
@@ -4461,7 +5297,7 @@
           <a:noFill/>
         </p:spPr>
         <p:txBody>
-          <a:bodyPr wrap="square">
+          <a:bodyPr wrap="square" lIns="45720" rIns="45720">
             <a:spAutoFit/>
           </a:bodyPr>
           <a:lstStyle/>
@@ -4472,7 +5308,7 @@
               </a:defRPr>
             </a:pPr>
             <a:r>
-              <a:rPr sz="3000" b="1">
+              <a:rPr sz="2600" b="1">
                 <a:solidFill>
                   <a:srgbClr val="2F7A5D"/>
                 </a:solidFill>
@@ -4491,8 +5327,8 @@
         </p:nvSpPr>
         <p:spPr>
           <a:xfrm>
-            <a:off x="9881372" y="3017520"/>
-            <a:ext cx="1670243" cy="548640"/>
+            <a:off x="9799076" y="2542032"/>
+            <a:ext cx="1798259" cy="329184"/>
           </a:xfrm>
           <a:prstGeom prst="rect">
             <a:avLst/>
@@ -4500,7 +5336,7 @@
           <a:noFill/>
         </p:spPr>
         <p:txBody>
-          <a:bodyPr wrap="square">
+          <a:bodyPr wrap="square" lIns="45720" rIns="45720">
             <a:spAutoFit/>
           </a:bodyPr>
           <a:lstStyle/>
@@ -4511,7 +5347,7 @@
               </a:defRPr>
             </a:pPr>
             <a:r>
-              <a:rPr sz="1100" b="0">
+              <a:rPr sz="1000" b="0">
                 <a:solidFill>
                   <a:srgbClr val="5F6F63"/>
                 </a:solidFill>
@@ -4531,7 +5367,7 @@
         <p:spPr>
           <a:xfrm>
             <a:off x="457200" y="6492240"/>
-            <a:ext cx="3657600" cy="274320"/>
+            <a:ext cx="2926080" cy="274320"/>
           </a:xfrm>
           <a:prstGeom prst="rect">
             <a:avLst/>
@@ -4539,7 +5375,7 @@
           <a:noFill/>
         </p:spPr>
         <p:txBody>
-          <a:bodyPr wrap="square">
+          <a:bodyPr wrap="square" lIns="45720" rIns="45720">
             <a:spAutoFit/>
           </a:bodyPr>
           <a:lstStyle/>
@@ -4569,8 +5405,8 @@
         </p:nvSpPr>
         <p:spPr>
           <a:xfrm>
-            <a:off x="4297680" y="6492240"/>
-            <a:ext cx="3657600" cy="274320"/>
+            <a:off x="3108960" y="6492240"/>
+            <a:ext cx="5943600" cy="274320"/>
           </a:xfrm>
           <a:prstGeom prst="rect">
             <a:avLst/>
@@ -4578,7 +5414,7 @@
           <a:noFill/>
         </p:spPr>
         <p:txBody>
-          <a:bodyPr wrap="square">
+          <a:bodyPr wrap="square" lIns="45720" rIns="45720">
             <a:spAutoFit/>
           </a:bodyPr>
           <a:lstStyle/>
@@ -4595,7 +5431,7 @@
                 </a:solidFill>
                 <a:latin typeface="Roboto"/>
               </a:rPr>
-              <a:t>Data retrieved 2pm, Tue 6 Oct 2026 · Sample data</a:t>
+              <a:t>Data retrieved 2pm, Tue 6 Oct 2026 · Generated 8 Oct 2026, 9:42am · Sample data · Made with Python (python-pptx)</a:t>
             </a:r>
           </a:p>
         </p:txBody>
@@ -4617,7 +5453,7 @@
           <a:noFill/>
         </p:spPr>
         <p:txBody>
-          <a:bodyPr wrap="square">
+          <a:bodyPr wrap="square" lIns="45720" rIns="45720">
             <a:spAutoFit/>
           </a:bodyPr>
           <a:lstStyle/>
@@ -4659,7 +5495,44 @@
       <p:grpSpPr/>
       <p:sp>
         <p:nvSpPr>
-          <p:cNvPr id="2" name="Rectangle 1"/>
+          <p:cNvPr id="2" name="Title 1"/>
+          <p:cNvSpPr>
+            <a:spLocks noGrp="1"/>
+          </p:cNvSpPr>
+          <p:nvPr>
+            <p:ph type="title"/>
+          </p:nvPr>
+        </p:nvSpPr>
+        <p:spPr>
+          <a:xfrm>
+            <a:off x="457200" y="384048"/>
+            <a:ext cx="11277295" cy="475488"/>
+          </a:xfrm>
+        </p:spPr>
+        <p:txBody>
+          <a:bodyPr wrap="square" lIns="45720" rIns="45720" tIns="0" bIns="0" anchor="t"/>
+          <a:lstStyle/>
+          <a:p>
+            <a:pPr algn="l">
+              <a:defRPr>
+                <a:latin typeface="Roboto"/>
+              </a:defRPr>
+            </a:pPr>
+            <a:r>
+              <a:rPr sz="2400" b="1">
+                <a:solidFill>
+                  <a:srgbClr val="25342A"/>
+                </a:solidFill>
+                <a:latin typeface="Roboto"/>
+              </a:rPr>
+              <a:t>Deliveries out, to customers · map</a:t>
+            </a:r>
+          </a:p>
+        </p:txBody>
+      </p:sp>
+      <p:sp>
+        <p:nvSpPr>
+          <p:cNvPr id="3" name="Rectangle 2"/>
           <p:cNvSpPr/>
           <p:nvPr/>
         </p:nvSpPr>
@@ -4706,53 +5579,14 @@
       </p:sp>
       <p:sp>
         <p:nvSpPr>
-          <p:cNvPr id="3" name="TextBox 2"/>
-          <p:cNvSpPr txBox="1"/>
-          <p:nvPr/>
-        </p:nvSpPr>
-        <p:spPr>
-          <a:xfrm>
-            <a:off x="457200" y="164592"/>
-            <a:ext cx="7315200" cy="274320"/>
-          </a:xfrm>
-          <a:prstGeom prst="rect">
-            <a:avLst/>
-          </a:prstGeom>
-          <a:noFill/>
-        </p:spPr>
-        <p:txBody>
-          <a:bodyPr wrap="square">
-            <a:spAutoFit/>
-          </a:bodyPr>
-          <a:lstStyle/>
-          <a:p>
-            <a:pPr>
-              <a:defRPr>
-                <a:latin typeface="Roboto"/>
-              </a:defRPr>
-            </a:pPr>
-            <a:r>
-              <a:rPr sz="1000" b="0">
-                <a:solidFill>
-                  <a:srgbClr val="5F6F63"/>
-                </a:solidFill>
-                <a:latin typeface="Roboto"/>
-              </a:rPr>
-              <a:t>Sample Distribution Pty Ltd · Deliveries in and out</a:t>
-            </a:r>
-          </a:p>
-        </p:txBody>
-      </p:sp>
-      <p:sp>
-        <p:nvSpPr>
           <p:cNvPr id="4" name="TextBox 3"/>
           <p:cNvSpPr txBox="1"/>
           <p:nvPr/>
         </p:nvSpPr>
         <p:spPr>
           <a:xfrm>
-            <a:off x="457200" y="411480"/>
-            <a:ext cx="11247120" cy="548640"/>
+            <a:off x="457200" y="146304"/>
+            <a:ext cx="8229600" cy="256032"/>
           </a:xfrm>
           <a:prstGeom prst="rect">
             <a:avLst/>
@@ -4760,7 +5594,7 @@
           <a:noFill/>
         </p:spPr>
         <p:txBody>
-          <a:bodyPr wrap="square">
+          <a:bodyPr wrap="square" lIns="45720" rIns="45720">
             <a:spAutoFit/>
           </a:bodyPr>
           <a:lstStyle/>
@@ -4771,13 +5605,13 @@
               </a:defRPr>
             </a:pPr>
             <a:r>
-              <a:rPr sz="2400" b="1">
-                <a:solidFill>
-                  <a:srgbClr val="25342A"/>
+              <a:rPr sz="1000" b="0">
+                <a:solidFill>
+                  <a:srgbClr val="5F6F63"/>
                 </a:solidFill>
                 <a:latin typeface="Roboto"/>
               </a:rPr>
-              <a:t>Deliveries out, to customers · map</a:t>
+              <a:t>Sample Distribution Pty Ltd · Deliveries in and out</a:t>
             </a:r>
           </a:p>
         </p:txBody>
@@ -4790,8 +5624,8 @@
         </p:nvSpPr>
         <p:spPr>
           <a:xfrm>
-            <a:off x="457200" y="960120"/>
-            <a:ext cx="11247120" cy="457200"/>
+            <a:off x="457200" y="914400"/>
+            <a:ext cx="11277295" cy="263652"/>
           </a:xfrm>
           <a:prstGeom prst="rect">
             <a:avLst/>
@@ -4799,7 +5633,7 @@
           <a:noFill/>
         </p:spPr>
         <p:txBody>
-          <a:bodyPr wrap="square">
+          <a:bodyPr wrap="square" lIns="45720" rIns="45720">
             <a:spAutoFit/>
           </a:bodyPr>
           <a:lstStyle/>
@@ -4816,7 +5650,7 @@
                 </a:solidFill>
                 <a:latin typeface="Roboto"/>
               </a:rPr>
-              <a:t>Green 95%+ on time · rose 80-95% · brick under 80% or overdue · grey-blue on its way. Dot size = number of deliveries.</a:t>
+              <a:t>Green 95%+ on time · amber 80-95% · brick under 80% or overdue · grey-blue on its way. Dot size = number of deliveries.</a:t>
             </a:r>
           </a:p>
         </p:txBody>
@@ -4830,15 +5664,15 @@
           <p:nvPr/>
         </p:nvPicPr>
         <p:blipFill>
-          <a:blip r:embed="rId2"/>
+          <a:blip r:embed="rId3"/>
           <a:stretch>
             <a:fillRect/>
           </a:stretch>
         </p:blipFill>
         <p:spPr>
           <a:xfrm>
-            <a:off x="457200" y="1463040"/>
-            <a:ext cx="9653058" cy="4754880"/>
+            <a:off x="457200" y="1278636"/>
+            <a:ext cx="9934605" cy="4893564"/>
           </a:xfrm>
           <a:prstGeom prst="rect">
             <a:avLst/>
@@ -4854,7 +5688,7 @@
         <p:spPr>
           <a:xfrm>
             <a:off x="457200" y="6492240"/>
-            <a:ext cx="3657600" cy="274320"/>
+            <a:ext cx="2926080" cy="274320"/>
           </a:xfrm>
           <a:prstGeom prst="rect">
             <a:avLst/>
@@ -4862,7 +5696,7 @@
           <a:noFill/>
         </p:spPr>
         <p:txBody>
-          <a:bodyPr wrap="square">
+          <a:bodyPr wrap="square" lIns="45720" rIns="45720">
             <a:spAutoFit/>
           </a:bodyPr>
           <a:lstStyle/>
@@ -4892,8 +5726,8 @@
         </p:nvSpPr>
         <p:spPr>
           <a:xfrm>
-            <a:off x="4297680" y="6492240"/>
-            <a:ext cx="3657600" cy="274320"/>
+            <a:off x="3108960" y="6492240"/>
+            <a:ext cx="5943600" cy="274320"/>
           </a:xfrm>
           <a:prstGeom prst="rect">
             <a:avLst/>
@@ -4901,7 +5735,7 @@
           <a:noFill/>
         </p:spPr>
         <p:txBody>
-          <a:bodyPr wrap="square">
+          <a:bodyPr wrap="square" lIns="45720" rIns="45720">
             <a:spAutoFit/>
           </a:bodyPr>
           <a:lstStyle/>
@@ -4918,7 +5752,7 @@
                 </a:solidFill>
                 <a:latin typeface="Roboto"/>
               </a:rPr>
-              <a:t>Data retrieved 2pm, Tue 6 Oct 2026 · Sample data</a:t>
+              <a:t>Data retrieved 2pm, Tue 6 Oct 2026 · Generated 8 Oct 2026, 9:42am · Sample data · Made with Python (python-pptx)</a:t>
             </a:r>
           </a:p>
         </p:txBody>
@@ -4940,7 +5774,7 @@
           <a:noFill/>
         </p:spPr>
         <p:txBody>
-          <a:bodyPr wrap="square">
+          <a:bodyPr wrap="square" lIns="45720" rIns="45720">
             <a:spAutoFit/>
           </a:bodyPr>
           <a:lstStyle/>
@@ -4982,7 +5816,44 @@
       <p:grpSpPr/>
       <p:sp>
         <p:nvSpPr>
-          <p:cNvPr id="2" name="Rectangle 1"/>
+          <p:cNvPr id="2" name="Title 1"/>
+          <p:cNvSpPr>
+            <a:spLocks noGrp="1"/>
+          </p:cNvSpPr>
+          <p:nvPr>
+            <p:ph type="title"/>
+          </p:nvPr>
+        </p:nvSpPr>
+        <p:spPr>
+          <a:xfrm>
+            <a:off x="457200" y="384048"/>
+            <a:ext cx="11277295" cy="475488"/>
+          </a:xfrm>
+        </p:spPr>
+        <p:txBody>
+          <a:bodyPr wrap="square" lIns="45720" rIns="45720" tIns="0" bIns="0" anchor="t"/>
+          <a:lstStyle/>
+          <a:p>
+            <a:pPr algn="l">
+              <a:defRPr>
+                <a:latin typeface="Roboto"/>
+              </a:defRPr>
+            </a:pPr>
+            <a:r>
+              <a:rPr sz="2400" b="1">
+                <a:solidFill>
+                  <a:srgbClr val="25342A"/>
+                </a:solidFill>
+                <a:latin typeface="Roboto"/>
+              </a:rPr>
+              <a:t>Deliveries out, to customers · where it's going wrong</a:t>
+            </a:r>
+          </a:p>
+        </p:txBody>
+      </p:sp>
+      <p:sp>
+        <p:nvSpPr>
+          <p:cNvPr id="3" name="Rectangle 2"/>
           <p:cNvSpPr/>
           <p:nvPr/>
         </p:nvSpPr>
@@ -5029,53 +5900,14 @@
       </p:sp>
       <p:sp>
         <p:nvSpPr>
-          <p:cNvPr id="3" name="TextBox 2"/>
-          <p:cNvSpPr txBox="1"/>
-          <p:nvPr/>
-        </p:nvSpPr>
-        <p:spPr>
-          <a:xfrm>
-            <a:off x="457200" y="164592"/>
-            <a:ext cx="7315200" cy="274320"/>
-          </a:xfrm>
-          <a:prstGeom prst="rect">
-            <a:avLst/>
-          </a:prstGeom>
-          <a:noFill/>
-        </p:spPr>
-        <p:txBody>
-          <a:bodyPr wrap="square">
-            <a:spAutoFit/>
-          </a:bodyPr>
-          <a:lstStyle/>
-          <a:p>
-            <a:pPr>
-              <a:defRPr>
-                <a:latin typeface="Roboto"/>
-              </a:defRPr>
-            </a:pPr>
-            <a:r>
-              <a:rPr sz="1000" b="0">
-                <a:solidFill>
-                  <a:srgbClr val="5F6F63"/>
-                </a:solidFill>
-                <a:latin typeface="Roboto"/>
-              </a:rPr>
-              <a:t>Sample Distribution Pty Ltd · Deliveries in and out</a:t>
-            </a:r>
-          </a:p>
-        </p:txBody>
-      </p:sp>
-      <p:sp>
-        <p:nvSpPr>
           <p:cNvPr id="4" name="TextBox 3"/>
           <p:cNvSpPr txBox="1"/>
           <p:nvPr/>
         </p:nvSpPr>
         <p:spPr>
           <a:xfrm>
-            <a:off x="457200" y="411480"/>
-            <a:ext cx="11247120" cy="548640"/>
+            <a:off x="457200" y="146304"/>
+            <a:ext cx="8229600" cy="256032"/>
           </a:xfrm>
           <a:prstGeom prst="rect">
             <a:avLst/>
@@ -5083,7 +5915,7 @@
           <a:noFill/>
         </p:spPr>
         <p:txBody>
-          <a:bodyPr wrap="square">
+          <a:bodyPr wrap="square" lIns="45720" rIns="45720">
             <a:spAutoFit/>
           </a:bodyPr>
           <a:lstStyle/>
@@ -5094,13 +5926,13 @@
               </a:defRPr>
             </a:pPr>
             <a:r>
-              <a:rPr sz="2400" b="1">
-                <a:solidFill>
-                  <a:srgbClr val="25342A"/>
+              <a:rPr sz="1000" b="0">
+                <a:solidFill>
+                  <a:srgbClr val="5F6F63"/>
                 </a:solidFill>
                 <a:latin typeface="Roboto"/>
               </a:rPr>
-              <a:t>Deliveries out, to customers · where it's going wrong</a:t>
+              <a:t>Sample Distribution Pty Ltd · Deliveries in and out</a:t>
             </a:r>
           </a:p>
         </p:txBody>
@@ -5114,8 +5946,8 @@
           <p:nvPr/>
         </p:nvGraphicFramePr>
         <p:xfrm>
-          <a:off x="457200" y="1188720"/>
-          <a:ext cx="11247120" cy="1316736"/>
+          <a:off x="457200" y="960120"/>
+          <a:ext cx="11277295" cy="1243584"/>
         </p:xfrm>
         <a:graphic>
           <a:graphicData uri="http://schemas.openxmlformats.org/drawingml/2006/table">
@@ -5124,18 +5956,18 @@
                 <a:tableStyleId>{5C22544A-7EE6-4342-B048-85BDC9FD1C3A}</a:tableStyleId>
               </a:tblPr>
               <a:tblGrid>
-                <a:gridCol w="2811780"/>
-                <a:gridCol w="2811780"/>
-                <a:gridCol w="2811780"/>
-                <a:gridCol w="2811780"/>
+                <a:gridCol w="2819323"/>
+                <a:gridCol w="2819323"/>
+                <a:gridCol w="2819323"/>
+                <a:gridCol w="2819326"/>
               </a:tblGrid>
-              <a:tr h="329184">
+              <a:tr h="310896">
                 <a:tc>
                   <a:txBody>
                     <a:bodyPr/>
                     <a:lstStyle/>
                     <a:p>
-                      <a:pPr>
+                      <a:pPr algn="l">
                         <a:defRPr>
                           <a:latin typeface="Roboto"/>
                         </a:defRPr>
@@ -5230,13 +6062,13 @@
                   </a:tcPr>
                 </a:tc>
               </a:tr>
-              <a:tr h="329184">
+              <a:tr h="310896">
                 <a:tc>
                   <a:txBody>
                     <a:bodyPr/>
                     <a:lstStyle/>
                     <a:p>
-                      <a:pPr>
+                      <a:pPr algn="l">
                         <a:defRPr>
                           <a:latin typeface="Roboto"/>
                         </a:defRPr>
@@ -5340,13 +6172,13 @@
                   </a:tcPr>
                 </a:tc>
               </a:tr>
-              <a:tr h="329184">
+              <a:tr h="310896">
                 <a:tc>
                   <a:txBody>
                     <a:bodyPr/>
                     <a:lstStyle/>
                     <a:p>
-                      <a:pPr>
+                      <a:pPr algn="l">
                         <a:defRPr>
                           <a:latin typeface="Roboto"/>
                         </a:defRPr>
@@ -5450,13 +6282,13 @@
                   </a:tcPr>
                 </a:tc>
               </a:tr>
-              <a:tr h="329184">
+              <a:tr h="310896">
                 <a:tc>
                   <a:txBody>
                     <a:bodyPr/>
                     <a:lstStyle/>
                     <a:p>
-                      <a:pPr>
+                      <a:pPr algn="l">
                         <a:defRPr>
                           <a:latin typeface="Roboto"/>
                         </a:defRPr>
@@ -5573,7 +6405,7 @@
         <p:spPr>
           <a:xfrm>
             <a:off x="457200" y="6492240"/>
-            <a:ext cx="3657600" cy="274320"/>
+            <a:ext cx="2926080" cy="274320"/>
           </a:xfrm>
           <a:prstGeom prst="rect">
             <a:avLst/>
@@ -5581,7 +6413,7 @@
           <a:noFill/>
         </p:spPr>
         <p:txBody>
-          <a:bodyPr wrap="square">
+          <a:bodyPr wrap="square" lIns="45720" rIns="45720">
             <a:spAutoFit/>
           </a:bodyPr>
           <a:lstStyle/>
@@ -5611,8 +6443,8 @@
         </p:nvSpPr>
         <p:spPr>
           <a:xfrm>
-            <a:off x="4297680" y="6492240"/>
-            <a:ext cx="3657600" cy="274320"/>
+            <a:off x="3108960" y="6492240"/>
+            <a:ext cx="5943600" cy="274320"/>
           </a:xfrm>
           <a:prstGeom prst="rect">
             <a:avLst/>
@@ -5620,7 +6452,7 @@
           <a:noFill/>
         </p:spPr>
         <p:txBody>
-          <a:bodyPr wrap="square">
+          <a:bodyPr wrap="square" lIns="45720" rIns="45720">
             <a:spAutoFit/>
           </a:bodyPr>
           <a:lstStyle/>
@@ -5637,7 +6469,7 @@
                 </a:solidFill>
                 <a:latin typeface="Roboto"/>
               </a:rPr>
-              <a:t>Data retrieved 2pm, Tue 6 Oct 2026 · Sample data</a:t>
+              <a:t>Data retrieved 2pm, Tue 6 Oct 2026 · Generated 8 Oct 2026, 9:42am · Sample data · Made with Python (python-pptx)</a:t>
             </a:r>
           </a:p>
         </p:txBody>
@@ -5659,7 +6491,7 @@
           <a:noFill/>
         </p:spPr>
         <p:txBody>
-          <a:bodyPr wrap="square">
+          <a:bodyPr wrap="square" lIns="45720" rIns="45720">
             <a:spAutoFit/>
           </a:bodyPr>
           <a:lstStyle/>
@@ -5701,7 +6533,44 @@
       <p:grpSpPr/>
       <p:sp>
         <p:nvSpPr>
-          <p:cNvPr id="2" name="Rectangle 1"/>
+          <p:cNvPr id="2" name="Title 1"/>
+          <p:cNvSpPr>
+            <a:spLocks noGrp="1"/>
+          </p:cNvSpPr>
+          <p:nvPr>
+            <p:ph type="title"/>
+          </p:nvPr>
+        </p:nvSpPr>
+        <p:spPr>
+          <a:xfrm>
+            <a:off x="457200" y="384048"/>
+            <a:ext cx="11277295" cy="475488"/>
+          </a:xfrm>
+        </p:spPr>
+        <p:txBody>
+          <a:bodyPr wrap="square" lIns="45720" rIns="45720" tIns="0" bIns="0" anchor="t"/>
+          <a:lstStyle/>
+          <a:p>
+            <a:pPr algn="l">
+              <a:defRPr>
+                <a:latin typeface="Roboto"/>
+              </a:defRPr>
+            </a:pPr>
+            <a:r>
+              <a:rPr sz="2400" b="1">
+                <a:solidFill>
+                  <a:srgbClr val="25342A"/>
+                </a:solidFill>
+                <a:latin typeface="Roboto"/>
+              </a:rPr>
+              <a:t>Deliveries in, from suppliers · last 30 days</a:t>
+            </a:r>
+          </a:p>
+        </p:txBody>
+      </p:sp>
+      <p:sp>
+        <p:nvSpPr>
+          <p:cNvPr id="3" name="Rectangle 2"/>
           <p:cNvSpPr/>
           <p:nvPr/>
         </p:nvSpPr>
@@ -5748,53 +6617,14 @@
       </p:sp>
       <p:sp>
         <p:nvSpPr>
-          <p:cNvPr id="3" name="TextBox 2"/>
-          <p:cNvSpPr txBox="1"/>
-          <p:nvPr/>
-        </p:nvSpPr>
-        <p:spPr>
-          <a:xfrm>
-            <a:off x="457200" y="164592"/>
-            <a:ext cx="7315200" cy="274320"/>
-          </a:xfrm>
-          <a:prstGeom prst="rect">
-            <a:avLst/>
-          </a:prstGeom>
-          <a:noFill/>
-        </p:spPr>
-        <p:txBody>
-          <a:bodyPr wrap="square">
-            <a:spAutoFit/>
-          </a:bodyPr>
-          <a:lstStyle/>
-          <a:p>
-            <a:pPr>
-              <a:defRPr>
-                <a:latin typeface="Roboto"/>
-              </a:defRPr>
-            </a:pPr>
-            <a:r>
-              <a:rPr sz="1000" b="0">
-                <a:solidFill>
-                  <a:srgbClr val="5F6F63"/>
-                </a:solidFill>
-                <a:latin typeface="Roboto"/>
-              </a:rPr>
-              <a:t>Sample Distribution Pty Ltd · Deliveries in and out</a:t>
-            </a:r>
-          </a:p>
-        </p:txBody>
-      </p:sp>
-      <p:sp>
-        <p:nvSpPr>
           <p:cNvPr id="4" name="TextBox 3"/>
           <p:cNvSpPr txBox="1"/>
           <p:nvPr/>
         </p:nvSpPr>
         <p:spPr>
           <a:xfrm>
-            <a:off x="457200" y="411480"/>
-            <a:ext cx="11247120" cy="548640"/>
+            <a:off x="457200" y="146304"/>
+            <a:ext cx="8229600" cy="256032"/>
           </a:xfrm>
           <a:prstGeom prst="rect">
             <a:avLst/>
@@ -5802,7 +6632,7 @@
           <a:noFill/>
         </p:spPr>
         <p:txBody>
-          <a:bodyPr wrap="square">
+          <a:bodyPr wrap="square" lIns="45720" rIns="45720">
             <a:spAutoFit/>
           </a:bodyPr>
           <a:lstStyle/>
@@ -5813,13 +6643,13 @@
               </a:defRPr>
             </a:pPr>
             <a:r>
-              <a:rPr sz="2400" b="1">
-                <a:solidFill>
-                  <a:srgbClr val="25342A"/>
+              <a:rPr sz="1000" b="0">
+                <a:solidFill>
+                  <a:srgbClr val="5F6F63"/>
                 </a:solidFill>
                 <a:latin typeface="Roboto"/>
               </a:rPr>
-              <a:t>Deliveries in, from suppliers · last 30 days</a:t>
+              <a:t>Sample Distribution Pty Ltd · Deliveries in and out</a:t>
             </a:r>
           </a:p>
         </p:txBody>
@@ -5832,8 +6662,8 @@
         </p:nvSpPr>
         <p:spPr>
           <a:xfrm>
-            <a:off x="457200" y="1645920"/>
-            <a:ext cx="2036003" cy="2011680"/>
+            <a:off x="457200" y="1188720"/>
+            <a:ext cx="2072579" cy="1737360"/>
           </a:xfrm>
           <a:prstGeom prst="rect">
             <a:avLst/>
@@ -5881,8 +6711,8 @@
         </p:nvSpPr>
         <p:spPr>
           <a:xfrm>
-            <a:off x="640080" y="1783080"/>
-            <a:ext cx="1670243" cy="457200"/>
+            <a:off x="594360" y="1261872"/>
+            <a:ext cx="1798259" cy="384048"/>
           </a:xfrm>
           <a:prstGeom prst="rect">
             <a:avLst/>
@@ -5890,7 +6720,7 @@
           <a:noFill/>
         </p:spPr>
         <p:txBody>
-          <a:bodyPr wrap="square">
+          <a:bodyPr wrap="square" lIns="45720" rIns="45720">
             <a:spAutoFit/>
           </a:bodyPr>
           <a:lstStyle/>
@@ -5901,7 +6731,7 @@
               </a:defRPr>
             </a:pPr>
             <a:r>
-              <a:rPr sz="1200" b="0">
+              <a:rPr sz="1100" b="0">
                 <a:solidFill>
                   <a:srgbClr val="5F6F63"/>
                 </a:solidFill>
@@ -5920,8 +6750,8 @@
         </p:nvSpPr>
         <p:spPr>
           <a:xfrm>
-            <a:off x="640080" y="2240280"/>
-            <a:ext cx="1670243" cy="731520"/>
+            <a:off x="594360" y="1627632"/>
+            <a:ext cx="1798259" cy="502920"/>
           </a:xfrm>
           <a:prstGeom prst="rect">
             <a:avLst/>
@@ -5929,7 +6759,7 @@
           <a:noFill/>
         </p:spPr>
         <p:txBody>
-          <a:bodyPr wrap="square">
+          <a:bodyPr wrap="square" lIns="45720" rIns="45720">
             <a:spAutoFit/>
           </a:bodyPr>
           <a:lstStyle/>
@@ -5940,7 +6770,7 @@
               </a:defRPr>
             </a:pPr>
             <a:r>
-              <a:rPr sz="3000" b="1">
+              <a:rPr sz="2600" b="1">
                 <a:solidFill>
                   <a:srgbClr val="2F7A5D"/>
                 </a:solidFill>
@@ -5959,8 +6789,8 @@
         </p:nvSpPr>
         <p:spPr>
           <a:xfrm>
-            <a:off x="640080" y="3017520"/>
-            <a:ext cx="1670243" cy="548640"/>
+            <a:off x="594360" y="2542032"/>
+            <a:ext cx="1798259" cy="329184"/>
           </a:xfrm>
           <a:prstGeom prst="rect">
             <a:avLst/>
@@ -5968,7 +6798,7 @@
           <a:noFill/>
         </p:spPr>
         <p:txBody>
-          <a:bodyPr wrap="square">
+          <a:bodyPr wrap="square" lIns="45720" rIns="45720">
             <a:spAutoFit/>
           </a:bodyPr>
           <a:lstStyle/>
@@ -5979,7 +6809,7 @@
               </a:defRPr>
             </a:pPr>
             <a:r>
-              <a:rPr sz="1100" b="0">
+              <a:rPr sz="1000" b="0">
                 <a:solidFill>
                   <a:srgbClr val="5F6F63"/>
                 </a:solidFill>
@@ -5998,8 +6828,8 @@
         </p:nvSpPr>
         <p:spPr>
           <a:xfrm>
-            <a:off x="2767523" y="1645920"/>
-            <a:ext cx="2036003" cy="2011680"/>
+            <a:off x="2758379" y="1188720"/>
+            <a:ext cx="2072579" cy="1737360"/>
           </a:xfrm>
           <a:prstGeom prst="rect">
             <a:avLst/>
@@ -6047,8 +6877,8 @@
         </p:nvSpPr>
         <p:spPr>
           <a:xfrm>
-            <a:off x="2950403" y="1783080"/>
-            <a:ext cx="1670243" cy="457200"/>
+            <a:off x="2895539" y="1261872"/>
+            <a:ext cx="1798259" cy="384048"/>
           </a:xfrm>
           <a:prstGeom prst="rect">
             <a:avLst/>
@@ -6056,7 +6886,7 @@
           <a:noFill/>
         </p:spPr>
         <p:txBody>
-          <a:bodyPr wrap="square">
+          <a:bodyPr wrap="square" lIns="45720" rIns="45720">
             <a:spAutoFit/>
           </a:bodyPr>
           <a:lstStyle/>
@@ -6067,7 +6897,7 @@
               </a:defRPr>
             </a:pPr>
             <a:r>
-              <a:rPr sz="1200" b="0">
+              <a:rPr sz="1100" b="0">
                 <a:solidFill>
                   <a:srgbClr val="5F6F63"/>
                 </a:solidFill>
@@ -6086,8 +6916,8 @@
         </p:nvSpPr>
         <p:spPr>
           <a:xfrm>
-            <a:off x="2950403" y="2240280"/>
-            <a:ext cx="1670243" cy="731520"/>
+            <a:off x="2895539" y="1627632"/>
+            <a:ext cx="1798259" cy="502920"/>
           </a:xfrm>
           <a:prstGeom prst="rect">
             <a:avLst/>
@@ -6095,7 +6925,7 @@
           <a:noFill/>
         </p:spPr>
         <p:txBody>
-          <a:bodyPr wrap="square">
+          <a:bodyPr wrap="square" lIns="45720" rIns="45720">
             <a:spAutoFit/>
           </a:bodyPr>
           <a:lstStyle/>
@@ -6106,7 +6936,7 @@
               </a:defRPr>
             </a:pPr>
             <a:r>
-              <a:rPr sz="3000" b="1">
+              <a:rPr sz="2600" b="1">
                 <a:solidFill>
                   <a:srgbClr val="2F7A5D"/>
                 </a:solidFill>
@@ -6125,8 +6955,8 @@
         </p:nvSpPr>
         <p:spPr>
           <a:xfrm>
-            <a:off x="2950403" y="3017520"/>
-            <a:ext cx="1670243" cy="548640"/>
+            <a:off x="2895539" y="2542032"/>
+            <a:ext cx="1798259" cy="329184"/>
           </a:xfrm>
           <a:prstGeom prst="rect">
             <a:avLst/>
@@ -6134,7 +6964,7 @@
           <a:noFill/>
         </p:spPr>
         <p:txBody>
-          <a:bodyPr wrap="square">
+          <a:bodyPr wrap="square" lIns="45720" rIns="45720">
             <a:spAutoFit/>
           </a:bodyPr>
           <a:lstStyle/>
@@ -6145,7 +6975,7 @@
               </a:defRPr>
             </a:pPr>
             <a:r>
-              <a:rPr sz="1100" b="0">
+              <a:rPr sz="1000" b="0">
                 <a:solidFill>
                   <a:srgbClr val="5F6F63"/>
                 </a:solidFill>
@@ -6164,8 +6994,8 @@
         </p:nvSpPr>
         <p:spPr>
           <a:xfrm>
-            <a:off x="5077846" y="1645920"/>
-            <a:ext cx="2036003" cy="2011680"/>
+            <a:off x="5059558" y="1188720"/>
+            <a:ext cx="2072579" cy="1737360"/>
           </a:xfrm>
           <a:prstGeom prst="rect">
             <a:avLst/>
@@ -6213,8 +7043,8 @@
         </p:nvSpPr>
         <p:spPr>
           <a:xfrm>
-            <a:off x="5260726" y="1783080"/>
-            <a:ext cx="1670243" cy="457200"/>
+            <a:off x="5196718" y="1261872"/>
+            <a:ext cx="1798259" cy="384048"/>
           </a:xfrm>
           <a:prstGeom prst="rect">
             <a:avLst/>
@@ -6222,7 +7052,7 @@
           <a:noFill/>
         </p:spPr>
         <p:txBody>
-          <a:bodyPr wrap="square">
+          <a:bodyPr wrap="square" lIns="45720" rIns="45720">
             <a:spAutoFit/>
           </a:bodyPr>
           <a:lstStyle/>
@@ -6233,7 +7063,7 @@
               </a:defRPr>
             </a:pPr>
             <a:r>
-              <a:rPr sz="1200" b="0">
+              <a:rPr sz="1100" b="0">
                 <a:solidFill>
                   <a:srgbClr val="5F6F63"/>
                 </a:solidFill>
@@ -6252,8 +7082,8 @@
         </p:nvSpPr>
         <p:spPr>
           <a:xfrm>
-            <a:off x="5260726" y="2240280"/>
-            <a:ext cx="1670243" cy="731520"/>
+            <a:off x="5196718" y="1627632"/>
+            <a:ext cx="1798259" cy="502920"/>
           </a:xfrm>
           <a:prstGeom prst="rect">
             <a:avLst/>
@@ -6261,7 +7091,7 @@
           <a:noFill/>
         </p:spPr>
         <p:txBody>
-          <a:bodyPr wrap="square">
+          <a:bodyPr wrap="square" lIns="45720" rIns="45720">
             <a:spAutoFit/>
           </a:bodyPr>
           <a:lstStyle/>
@@ -6272,7 +7102,7 @@
               </a:defRPr>
             </a:pPr>
             <a:r>
-              <a:rPr sz="3000" b="1">
+              <a:rPr sz="2600" b="1">
                 <a:solidFill>
                   <a:srgbClr val="2F7A5D"/>
                 </a:solidFill>
@@ -6291,8 +7121,8 @@
         </p:nvSpPr>
         <p:spPr>
           <a:xfrm>
-            <a:off x="5260726" y="3017520"/>
-            <a:ext cx="1670243" cy="548640"/>
+            <a:off x="5196718" y="2542032"/>
+            <a:ext cx="1798259" cy="329184"/>
           </a:xfrm>
           <a:prstGeom prst="rect">
             <a:avLst/>
@@ -6300,7 +7130,7 @@
           <a:noFill/>
         </p:spPr>
         <p:txBody>
-          <a:bodyPr wrap="square">
+          <a:bodyPr wrap="square" lIns="45720" rIns="45720">
             <a:spAutoFit/>
           </a:bodyPr>
           <a:lstStyle/>
@@ -6311,7 +7141,7 @@
               </a:defRPr>
             </a:pPr>
             <a:r>
-              <a:rPr sz="1100" b="0">
+              <a:rPr sz="1000" b="0">
                 <a:solidFill>
                   <a:srgbClr val="5F6F63"/>
                 </a:solidFill>
@@ -6330,8 +7160,8 @@
         </p:nvSpPr>
         <p:spPr>
           <a:xfrm>
-            <a:off x="7388169" y="1645920"/>
-            <a:ext cx="2036003" cy="2011680"/>
+            <a:off x="7360737" y="1188720"/>
+            <a:ext cx="2072579" cy="1737360"/>
           </a:xfrm>
           <a:prstGeom prst="rect">
             <a:avLst/>
@@ -6379,8 +7209,8 @@
         </p:nvSpPr>
         <p:spPr>
           <a:xfrm>
-            <a:off x="7571049" y="1783080"/>
-            <a:ext cx="1670243" cy="457200"/>
+            <a:off x="7497897" y="1261872"/>
+            <a:ext cx="1798259" cy="384048"/>
           </a:xfrm>
           <a:prstGeom prst="rect">
             <a:avLst/>
@@ -6388,7 +7218,7 @@
           <a:noFill/>
         </p:spPr>
         <p:txBody>
-          <a:bodyPr wrap="square">
+          <a:bodyPr wrap="square" lIns="45720" rIns="45720">
             <a:spAutoFit/>
           </a:bodyPr>
           <a:lstStyle/>
@@ -6399,7 +7229,7 @@
               </a:defRPr>
             </a:pPr>
             <a:r>
-              <a:rPr sz="1200" b="0">
+              <a:rPr sz="1100" b="0">
                 <a:solidFill>
                   <a:srgbClr val="5F6F63"/>
                 </a:solidFill>
@@ -6418,8 +7248,8 @@
         </p:nvSpPr>
         <p:spPr>
           <a:xfrm>
-            <a:off x="7571049" y="2240280"/>
-            <a:ext cx="1670243" cy="731520"/>
+            <a:off x="7497897" y="1627632"/>
+            <a:ext cx="1798259" cy="502920"/>
           </a:xfrm>
           <a:prstGeom prst="rect">
             <a:avLst/>
@@ -6427,7 +7257,7 @@
           <a:noFill/>
         </p:spPr>
         <p:txBody>
-          <a:bodyPr wrap="square">
+          <a:bodyPr wrap="square" lIns="45720" rIns="45720">
             <a:spAutoFit/>
           </a:bodyPr>
           <a:lstStyle/>
@@ -6438,7 +7268,7 @@
               </a:defRPr>
             </a:pPr>
             <a:r>
-              <a:rPr sz="3000" b="1">
+              <a:rPr sz="2600" b="1">
                 <a:solidFill>
                   <a:srgbClr val="2F7A5D"/>
                 </a:solidFill>
@@ -6457,8 +7287,8 @@
         </p:nvSpPr>
         <p:spPr>
           <a:xfrm>
-            <a:off x="7571049" y="3017520"/>
-            <a:ext cx="1670243" cy="548640"/>
+            <a:off x="7497897" y="2542032"/>
+            <a:ext cx="1798259" cy="329184"/>
           </a:xfrm>
           <a:prstGeom prst="rect">
             <a:avLst/>
@@ -6466,7 +7296,7 @@
           <a:noFill/>
         </p:spPr>
         <p:txBody>
-          <a:bodyPr wrap="square">
+          <a:bodyPr wrap="square" lIns="45720" rIns="45720">
             <a:spAutoFit/>
           </a:bodyPr>
           <a:lstStyle/>
@@ -6477,7 +7307,7 @@
               </a:defRPr>
             </a:pPr>
             <a:r>
-              <a:rPr sz="1100" b="0">
+              <a:rPr sz="1000" b="0">
                 <a:solidFill>
                   <a:srgbClr val="5F6F63"/>
                 </a:solidFill>
@@ -6496,8 +7326,8 @@
         </p:nvSpPr>
         <p:spPr>
           <a:xfrm>
-            <a:off x="9698492" y="1645920"/>
-            <a:ext cx="2036003" cy="2011680"/>
+            <a:off x="9661916" y="1188720"/>
+            <a:ext cx="2072579" cy="1737360"/>
           </a:xfrm>
           <a:prstGeom prst="rect">
             <a:avLst/>
@@ -6545,8 +7375,8 @@
         </p:nvSpPr>
         <p:spPr>
           <a:xfrm>
-            <a:off x="9881372" y="1783080"/>
-            <a:ext cx="1670243" cy="457200"/>
+            <a:off x="9799076" y="1261872"/>
+            <a:ext cx="1798259" cy="384048"/>
           </a:xfrm>
           <a:prstGeom prst="rect">
             <a:avLst/>
@@ -6554,7 +7384,7 @@
           <a:noFill/>
         </p:spPr>
         <p:txBody>
-          <a:bodyPr wrap="square">
+          <a:bodyPr wrap="square" lIns="45720" rIns="45720">
             <a:spAutoFit/>
           </a:bodyPr>
           <a:lstStyle/>
@@ -6565,7 +7395,7 @@
               </a:defRPr>
             </a:pPr>
             <a:r>
-              <a:rPr sz="1200" b="0">
+              <a:rPr sz="1100" b="0">
                 <a:solidFill>
                   <a:srgbClr val="5F6F63"/>
                 </a:solidFill>
@@ -6584,8 +7414,8 @@
         </p:nvSpPr>
         <p:spPr>
           <a:xfrm>
-            <a:off x="9881372" y="2240280"/>
-            <a:ext cx="1670243" cy="731520"/>
+            <a:off x="9799076" y="1627632"/>
+            <a:ext cx="1798259" cy="502920"/>
           </a:xfrm>
           <a:prstGeom prst="rect">
             <a:avLst/>
@@ -6593,7 +7423,7 @@
           <a:noFill/>
         </p:spPr>
         <p:txBody>
-          <a:bodyPr wrap="square">
+          <a:bodyPr wrap="square" lIns="45720" rIns="45720">
             <a:spAutoFit/>
           </a:bodyPr>
           <a:lstStyle/>
@@ -6604,7 +7434,7 @@
               </a:defRPr>
             </a:pPr>
             <a:r>
-              <a:rPr sz="3000" b="1">
+              <a:rPr sz="2600" b="1">
                 <a:solidFill>
                   <a:srgbClr val="2F7A5D"/>
                 </a:solidFill>
@@ -6623,8 +7453,8 @@
         </p:nvSpPr>
         <p:spPr>
           <a:xfrm>
-            <a:off x="9881372" y="3017520"/>
-            <a:ext cx="1670243" cy="548640"/>
+            <a:off x="9799076" y="2542032"/>
+            <a:ext cx="1798259" cy="329184"/>
           </a:xfrm>
           <a:prstGeom prst="rect">
             <a:avLst/>
@@ -6632,7 +7462,7 @@
           <a:noFill/>
         </p:spPr>
         <p:txBody>
-          <a:bodyPr wrap="square">
+          <a:bodyPr wrap="square" lIns="45720" rIns="45720">
             <a:spAutoFit/>
           </a:bodyPr>
           <a:lstStyle/>
@@ -6643,7 +7473,7 @@
               </a:defRPr>
             </a:pPr>
             <a:r>
-              <a:rPr sz="1100" b="0">
+              <a:rPr sz="1000" b="0">
                 <a:solidFill>
                   <a:srgbClr val="5F6F63"/>
                 </a:solidFill>
@@ -6663,7 +7493,7 @@
         <p:spPr>
           <a:xfrm>
             <a:off x="457200" y="6492240"/>
-            <a:ext cx="3657600" cy="274320"/>
+            <a:ext cx="2926080" cy="274320"/>
           </a:xfrm>
           <a:prstGeom prst="rect">
             <a:avLst/>
@@ -6671,7 +7501,7 @@
           <a:noFill/>
         </p:spPr>
         <p:txBody>
-          <a:bodyPr wrap="square">
+          <a:bodyPr wrap="square" lIns="45720" rIns="45720">
             <a:spAutoFit/>
           </a:bodyPr>
           <a:lstStyle/>
@@ -6701,8 +7531,8 @@
         </p:nvSpPr>
         <p:spPr>
           <a:xfrm>
-            <a:off x="4297680" y="6492240"/>
-            <a:ext cx="3657600" cy="274320"/>
+            <a:off x="3108960" y="6492240"/>
+            <a:ext cx="5943600" cy="274320"/>
           </a:xfrm>
           <a:prstGeom prst="rect">
             <a:avLst/>
@@ -6710,7 +7540,7 @@
           <a:noFill/>
         </p:spPr>
         <p:txBody>
-          <a:bodyPr wrap="square">
+          <a:bodyPr wrap="square" lIns="45720" rIns="45720">
             <a:spAutoFit/>
           </a:bodyPr>
           <a:lstStyle/>
@@ -6727,7 +7557,7 @@
                 </a:solidFill>
                 <a:latin typeface="Roboto"/>
               </a:rPr>
-              <a:t>Data retrieved 2pm, Tue 6 Oct 2026 · Sample data</a:t>
+              <a:t>Data retrieved 2pm, Tue 6 Oct 2026 · Generated 8 Oct 2026, 9:42am · Sample data · Made with Python (python-pptx)</a:t>
             </a:r>
           </a:p>
         </p:txBody>
@@ -6749,7 +7579,7 @@
           <a:noFill/>
         </p:spPr>
         <p:txBody>
-          <a:bodyPr wrap="square">
+          <a:bodyPr wrap="square" lIns="45720" rIns="45720">
             <a:spAutoFit/>
           </a:bodyPr>
           <a:lstStyle/>
@@ -6791,7 +7621,44 @@
       <p:grpSpPr/>
       <p:sp>
         <p:nvSpPr>
-          <p:cNvPr id="2" name="Rectangle 1"/>
+          <p:cNvPr id="2" name="Title 1"/>
+          <p:cNvSpPr>
+            <a:spLocks noGrp="1"/>
+          </p:cNvSpPr>
+          <p:nvPr>
+            <p:ph type="title"/>
+          </p:nvPr>
+        </p:nvSpPr>
+        <p:spPr>
+          <a:xfrm>
+            <a:off x="457200" y="384048"/>
+            <a:ext cx="11277295" cy="475488"/>
+          </a:xfrm>
+        </p:spPr>
+        <p:txBody>
+          <a:bodyPr wrap="square" lIns="45720" rIns="45720" tIns="0" bIns="0" anchor="t"/>
+          <a:lstStyle/>
+          <a:p>
+            <a:pPr algn="l">
+              <a:defRPr>
+                <a:latin typeface="Roboto"/>
+              </a:defRPr>
+            </a:pPr>
+            <a:r>
+              <a:rPr sz="2400" b="1">
+                <a:solidFill>
+                  <a:srgbClr val="25342A"/>
+                </a:solidFill>
+                <a:latin typeface="Roboto"/>
+              </a:rPr>
+              <a:t>Deliveries in, from suppliers · map</a:t>
+            </a:r>
+          </a:p>
+        </p:txBody>
+      </p:sp>
+      <p:sp>
+        <p:nvSpPr>
+          <p:cNvPr id="3" name="Rectangle 2"/>
           <p:cNvSpPr/>
           <p:nvPr/>
         </p:nvSpPr>
@@ -6838,53 +7705,14 @@
       </p:sp>
       <p:sp>
         <p:nvSpPr>
-          <p:cNvPr id="3" name="TextBox 2"/>
-          <p:cNvSpPr txBox="1"/>
-          <p:nvPr/>
-        </p:nvSpPr>
-        <p:spPr>
-          <a:xfrm>
-            <a:off x="457200" y="164592"/>
-            <a:ext cx="7315200" cy="274320"/>
-          </a:xfrm>
-          <a:prstGeom prst="rect">
-            <a:avLst/>
-          </a:prstGeom>
-          <a:noFill/>
-        </p:spPr>
-        <p:txBody>
-          <a:bodyPr wrap="square">
-            <a:spAutoFit/>
-          </a:bodyPr>
-          <a:lstStyle/>
-          <a:p>
-            <a:pPr>
-              <a:defRPr>
-                <a:latin typeface="Roboto"/>
-              </a:defRPr>
-            </a:pPr>
-            <a:r>
-              <a:rPr sz="1000" b="0">
-                <a:solidFill>
-                  <a:srgbClr val="5F6F63"/>
-                </a:solidFill>
-                <a:latin typeface="Roboto"/>
-              </a:rPr>
-              <a:t>Sample Distribution Pty Ltd · Deliveries in and out</a:t>
-            </a:r>
-          </a:p>
-        </p:txBody>
-      </p:sp>
-      <p:sp>
-        <p:nvSpPr>
           <p:cNvPr id="4" name="TextBox 3"/>
           <p:cNvSpPr txBox="1"/>
           <p:nvPr/>
         </p:nvSpPr>
         <p:spPr>
           <a:xfrm>
-            <a:off x="457200" y="411480"/>
-            <a:ext cx="11247120" cy="548640"/>
+            <a:off x="457200" y="146304"/>
+            <a:ext cx="8229600" cy="256032"/>
           </a:xfrm>
           <a:prstGeom prst="rect">
             <a:avLst/>
@@ -6892,7 +7720,7 @@
           <a:noFill/>
         </p:spPr>
         <p:txBody>
-          <a:bodyPr wrap="square">
+          <a:bodyPr wrap="square" lIns="45720" rIns="45720">
             <a:spAutoFit/>
           </a:bodyPr>
           <a:lstStyle/>
@@ -6903,13 +7731,13 @@
               </a:defRPr>
             </a:pPr>
             <a:r>
-              <a:rPr sz="2400" b="1">
-                <a:solidFill>
-                  <a:srgbClr val="25342A"/>
+              <a:rPr sz="1000" b="0">
+                <a:solidFill>
+                  <a:srgbClr val="5F6F63"/>
                 </a:solidFill>
                 <a:latin typeface="Roboto"/>
               </a:rPr>
-              <a:t>Deliveries in, from suppliers · map</a:t>
+              <a:t>Sample Distribution Pty Ltd · Deliveries in and out</a:t>
             </a:r>
           </a:p>
         </p:txBody>
@@ -6922,8 +7750,8 @@
         </p:nvSpPr>
         <p:spPr>
           <a:xfrm>
-            <a:off x="457200" y="960120"/>
-            <a:ext cx="11247120" cy="457200"/>
+            <a:off x="457200" y="914400"/>
+            <a:ext cx="11277295" cy="263652"/>
           </a:xfrm>
           <a:prstGeom prst="rect">
             <a:avLst/>
@@ -6931,7 +7759,7 @@
           <a:noFill/>
         </p:spPr>
         <p:txBody>
-          <a:bodyPr wrap="square">
+          <a:bodyPr wrap="square" lIns="45720" rIns="45720">
             <a:spAutoFit/>
           </a:bodyPr>
           <a:lstStyle/>
@@ -6948,7 +7776,7 @@
                 </a:solidFill>
                 <a:latin typeface="Roboto"/>
               </a:rPr>
-              <a:t>Green 95%+ on time · rose 80-95% · brick under 80% or overdue · grey-blue on its way. Dot size = number of deliveries.</a:t>
+              <a:t>Green 95%+ on time · amber 80-95% · brick under 80% or overdue · grey-blue on its way. Dot size = number of deliveries.</a:t>
             </a:r>
           </a:p>
         </p:txBody>
@@ -6962,15 +7790,15 @@
           <p:nvPr/>
         </p:nvPicPr>
         <p:blipFill>
-          <a:blip r:embed="rId2"/>
+          <a:blip r:embed="rId3"/>
           <a:stretch>
             <a:fillRect/>
           </a:stretch>
         </p:blipFill>
         <p:spPr>
           <a:xfrm>
-            <a:off x="457200" y="1463040"/>
-            <a:ext cx="9626683" cy="4754880"/>
+            <a:off x="457200" y="1278636"/>
+            <a:ext cx="9907462" cy="4893564"/>
           </a:xfrm>
           <a:prstGeom prst="rect">
             <a:avLst/>
@@ -6986,7 +7814,7 @@
         <p:spPr>
           <a:xfrm>
             <a:off x="457200" y="6492240"/>
-            <a:ext cx="3657600" cy="274320"/>
+            <a:ext cx="2926080" cy="274320"/>
           </a:xfrm>
           <a:prstGeom prst="rect">
             <a:avLst/>
@@ -6994,7 +7822,7 @@
           <a:noFill/>
         </p:spPr>
         <p:txBody>
-          <a:bodyPr wrap="square">
+          <a:bodyPr wrap="square" lIns="45720" rIns="45720">
             <a:spAutoFit/>
           </a:bodyPr>
           <a:lstStyle/>
@@ -7024,8 +7852,8 @@
         </p:nvSpPr>
         <p:spPr>
           <a:xfrm>
-            <a:off x="4297680" y="6492240"/>
-            <a:ext cx="3657600" cy="274320"/>
+            <a:off x="3108960" y="6492240"/>
+            <a:ext cx="5943600" cy="274320"/>
           </a:xfrm>
           <a:prstGeom prst="rect">
             <a:avLst/>
@@ -7033,7 +7861,7 @@
           <a:noFill/>
         </p:spPr>
         <p:txBody>
-          <a:bodyPr wrap="square">
+          <a:bodyPr wrap="square" lIns="45720" rIns="45720">
             <a:spAutoFit/>
           </a:bodyPr>
           <a:lstStyle/>
@@ -7050,7 +7878,7 @@
                 </a:solidFill>
                 <a:latin typeface="Roboto"/>
               </a:rPr>
-              <a:t>Data retrieved 2pm, Tue 6 Oct 2026 · Sample data</a:t>
+              <a:t>Data retrieved 2pm, Tue 6 Oct 2026 · Generated 8 Oct 2026, 9:42am · Sample data · Made with Python (python-pptx)</a:t>
             </a:r>
           </a:p>
         </p:txBody>
@@ -7072,7 +7900,7 @@
           <a:noFill/>
         </p:spPr>
         <p:txBody>
-          <a:bodyPr wrap="square">
+          <a:bodyPr wrap="square" lIns="45720" rIns="45720">
             <a:spAutoFit/>
           </a:bodyPr>
           <a:lstStyle/>
@@ -7114,7 +7942,44 @@
       <p:grpSpPr/>
       <p:sp>
         <p:nvSpPr>
-          <p:cNvPr id="2" name="Rectangle 1"/>
+          <p:cNvPr id="2" name="Title 1"/>
+          <p:cNvSpPr>
+            <a:spLocks noGrp="1"/>
+          </p:cNvSpPr>
+          <p:nvPr>
+            <p:ph type="title"/>
+          </p:nvPr>
+        </p:nvSpPr>
+        <p:spPr>
+          <a:xfrm>
+            <a:off x="457200" y="384048"/>
+            <a:ext cx="11277295" cy="475488"/>
+          </a:xfrm>
+        </p:spPr>
+        <p:txBody>
+          <a:bodyPr wrap="square" lIns="45720" rIns="45720" tIns="0" bIns="0" anchor="t"/>
+          <a:lstStyle/>
+          <a:p>
+            <a:pPr algn="l">
+              <a:defRPr>
+                <a:latin typeface="Roboto"/>
+              </a:defRPr>
+            </a:pPr>
+            <a:r>
+              <a:rPr sz="2400" b="1">
+                <a:solidFill>
+                  <a:srgbClr val="25342A"/>
+                </a:solidFill>
+                <a:latin typeface="Roboto"/>
+              </a:rPr>
+              <a:t>Deliveries in, from suppliers · where it's going wrong</a:t>
+            </a:r>
+          </a:p>
+        </p:txBody>
+      </p:sp>
+      <p:sp>
+        <p:nvSpPr>
+          <p:cNvPr id="3" name="Rectangle 2"/>
           <p:cNvSpPr/>
           <p:nvPr/>
         </p:nvSpPr>
@@ -7161,53 +8026,14 @@
       </p:sp>
       <p:sp>
         <p:nvSpPr>
-          <p:cNvPr id="3" name="TextBox 2"/>
-          <p:cNvSpPr txBox="1"/>
-          <p:nvPr/>
-        </p:nvSpPr>
-        <p:spPr>
-          <a:xfrm>
-            <a:off x="457200" y="164592"/>
-            <a:ext cx="7315200" cy="274320"/>
-          </a:xfrm>
-          <a:prstGeom prst="rect">
-            <a:avLst/>
-          </a:prstGeom>
-          <a:noFill/>
-        </p:spPr>
-        <p:txBody>
-          <a:bodyPr wrap="square">
-            <a:spAutoFit/>
-          </a:bodyPr>
-          <a:lstStyle/>
-          <a:p>
-            <a:pPr>
-              <a:defRPr>
-                <a:latin typeface="Roboto"/>
-              </a:defRPr>
-            </a:pPr>
-            <a:r>
-              <a:rPr sz="1000" b="0">
-                <a:solidFill>
-                  <a:srgbClr val="5F6F63"/>
-                </a:solidFill>
-                <a:latin typeface="Roboto"/>
-              </a:rPr>
-              <a:t>Sample Distribution Pty Ltd · Deliveries in and out</a:t>
-            </a:r>
-          </a:p>
-        </p:txBody>
-      </p:sp>
-      <p:sp>
-        <p:nvSpPr>
           <p:cNvPr id="4" name="TextBox 3"/>
           <p:cNvSpPr txBox="1"/>
           <p:nvPr/>
         </p:nvSpPr>
         <p:spPr>
           <a:xfrm>
-            <a:off x="457200" y="411480"/>
-            <a:ext cx="11247120" cy="548640"/>
+            <a:off x="457200" y="146304"/>
+            <a:ext cx="8229600" cy="256032"/>
           </a:xfrm>
           <a:prstGeom prst="rect">
             <a:avLst/>
@@ -7215,7 +8041,7 @@
           <a:noFill/>
         </p:spPr>
         <p:txBody>
-          <a:bodyPr wrap="square">
+          <a:bodyPr wrap="square" lIns="45720" rIns="45720">
             <a:spAutoFit/>
           </a:bodyPr>
           <a:lstStyle/>
@@ -7226,13 +8052,13 @@
               </a:defRPr>
             </a:pPr>
             <a:r>
-              <a:rPr sz="2400" b="1">
-                <a:solidFill>
-                  <a:srgbClr val="25342A"/>
+              <a:rPr sz="1000" b="0">
+                <a:solidFill>
+                  <a:srgbClr val="5F6F63"/>
                 </a:solidFill>
                 <a:latin typeface="Roboto"/>
               </a:rPr>
-              <a:t>Deliveries in, from suppliers · where it's going wrong</a:t>
+              <a:t>Sample Distribution Pty Ltd · Deliveries in and out</a:t>
             </a:r>
           </a:p>
         </p:txBody>
@@ -7246,8 +8072,8 @@
           <p:nvPr/>
         </p:nvGraphicFramePr>
         <p:xfrm>
-          <a:off x="457200" y="1188720"/>
-          <a:ext cx="11247120" cy="1316736"/>
+          <a:off x="457200" y="960120"/>
+          <a:ext cx="11277295" cy="1243584"/>
         </p:xfrm>
         <a:graphic>
           <a:graphicData uri="http://schemas.openxmlformats.org/drawingml/2006/table">
@@ -7256,18 +8082,18 @@
                 <a:tableStyleId>{5C22544A-7EE6-4342-B048-85BDC9FD1C3A}</a:tableStyleId>
               </a:tblPr>
               <a:tblGrid>
-                <a:gridCol w="2811780"/>
-                <a:gridCol w="2811780"/>
-                <a:gridCol w="2811780"/>
-                <a:gridCol w="2811780"/>
+                <a:gridCol w="2819323"/>
+                <a:gridCol w="2819323"/>
+                <a:gridCol w="2819323"/>
+                <a:gridCol w="2819326"/>
               </a:tblGrid>
-              <a:tr h="329184">
+              <a:tr h="310896">
                 <a:tc>
                   <a:txBody>
                     <a:bodyPr/>
                     <a:lstStyle/>
                     <a:p>
-                      <a:pPr>
+                      <a:pPr algn="l">
                         <a:defRPr>
                           <a:latin typeface="Roboto"/>
                         </a:defRPr>
@@ -7362,13 +8188,13 @@
                   </a:tcPr>
                 </a:tc>
               </a:tr>
-              <a:tr h="329184">
+              <a:tr h="310896">
                 <a:tc>
                   <a:txBody>
                     <a:bodyPr/>
                     <a:lstStyle/>
                     <a:p>
-                      <a:pPr>
+                      <a:pPr algn="l">
                         <a:defRPr>
                           <a:latin typeface="Roboto"/>
                         </a:defRPr>
@@ -7472,13 +8298,13 @@
                   </a:tcPr>
                 </a:tc>
               </a:tr>
-              <a:tr h="329184">
+              <a:tr h="310896">
                 <a:tc>
                   <a:txBody>
                     <a:bodyPr/>
                     <a:lstStyle/>
                     <a:p>
-                      <a:pPr>
+                      <a:pPr algn="l">
                         <a:defRPr>
                           <a:latin typeface="Roboto"/>
                         </a:defRPr>
@@ -7582,13 +8408,13 @@
                   </a:tcPr>
                 </a:tc>
               </a:tr>
-              <a:tr h="329184">
+              <a:tr h="310896">
                 <a:tc>
                   <a:txBody>
                     <a:bodyPr/>
                     <a:lstStyle/>
                     <a:p>
-                      <a:pPr>
+                      <a:pPr algn="l">
                         <a:defRPr>
                           <a:latin typeface="Roboto"/>
                         </a:defRPr>
@@ -7705,7 +8531,7 @@
         <p:spPr>
           <a:xfrm>
             <a:off x="457200" y="6492240"/>
-            <a:ext cx="3657600" cy="274320"/>
+            <a:ext cx="2926080" cy="274320"/>
           </a:xfrm>
           <a:prstGeom prst="rect">
             <a:avLst/>
@@ -7713,7 +8539,7 @@
           <a:noFill/>
         </p:spPr>
         <p:txBody>
-          <a:bodyPr wrap="square">
+          <a:bodyPr wrap="square" lIns="45720" rIns="45720">
             <a:spAutoFit/>
           </a:bodyPr>
           <a:lstStyle/>
@@ -7743,8 +8569,8 @@
         </p:nvSpPr>
         <p:spPr>
           <a:xfrm>
-            <a:off x="4297680" y="6492240"/>
-            <a:ext cx="3657600" cy="274320"/>
+            <a:off x="3108960" y="6492240"/>
+            <a:ext cx="5943600" cy="274320"/>
           </a:xfrm>
           <a:prstGeom prst="rect">
             <a:avLst/>
@@ -7752,7 +8578,7 @@
           <a:noFill/>
         </p:spPr>
         <p:txBody>
-          <a:bodyPr wrap="square">
+          <a:bodyPr wrap="square" lIns="45720" rIns="45720">
             <a:spAutoFit/>
           </a:bodyPr>
           <a:lstStyle/>
@@ -7769,7 +8595,7 @@
                 </a:solidFill>
                 <a:latin typeface="Roboto"/>
               </a:rPr>
-              <a:t>Data retrieved 2pm, Tue 6 Oct 2026 · Sample data</a:t>
+              <a:t>Data retrieved 2pm, Tue 6 Oct 2026 · Generated 8 Oct 2026, 9:42am · Sample data · Made with Python (python-pptx)</a:t>
             </a:r>
           </a:p>
         </p:txBody>
@@ -7791,7 +8617,7 @@
           <a:noFill/>
         </p:spPr>
         <p:txBody>
-          <a:bodyPr wrap="square">
+          <a:bodyPr wrap="square" lIns="45720" rIns="45720">
             <a:spAutoFit/>
           </a:bodyPr>
           <a:lstStyle/>
@@ -7822,6 +8648,326 @@
 </file>
 
 <file path=ppt/theme/theme1.xml><?xml version="1.0" encoding="utf-8"?>
+<a:theme xmlns:a="http://schemas.openxmlformats.org/drawingml/2006/main" name="Office Theme">
+  <a:themeElements>
+    <a:clrScheme name="Office">
+      <a:dk1>
+        <a:sysClr val="windowText" lastClr="000000"/>
+      </a:dk1>
+      <a:lt1>
+        <a:sysClr val="window" lastClr="FFFFFF"/>
+      </a:lt1>
+      <a:dk2>
+        <a:srgbClr val="25342A"/>
+      </a:dk2>
+      <a:lt2>
+        <a:srgbClr val="F4F7F2"/>
+      </a:lt2>
+      <a:accent1>
+        <a:srgbClr val="2F7A5D"/>
+      </a:accent1>
+      <a:accent2>
+        <a:srgbClr val="0E9F6E"/>
+      </a:accent2>
+      <a:accent3>
+        <a:srgbClr val="7D8790"/>
+      </a:accent3>
+      <a:accent4>
+        <a:srgbClr val="8A6D3B"/>
+      </a:accent4>
+      <a:accent5>
+        <a:srgbClr val="B42318"/>
+      </a:accent5>
+      <a:accent6>
+        <a:srgbClr val="8E9CAB"/>
+      </a:accent6>
+      <a:hlink>
+        <a:srgbClr val="0000FF"/>
+      </a:hlink>
+      <a:folHlink>
+        <a:srgbClr val="800080"/>
+      </a:folHlink>
+    </a:clrScheme>
+    <a:fontScheme name="Office">
+      <a:majorFont>
+        <a:latin typeface="Roboto"/>
+        <a:ea typeface=""/>
+        <a:cs typeface=""/>
+        <a:font script="Jpan" typeface="ＭＳ Ｐゴシック"/>
+        <a:font script="Hang" typeface="맑은 고딕"/>
+        <a:font script="Hans" typeface="宋体"/>
+        <a:font script="Hant" typeface="新細明體"/>
+        <a:font script="Arab" typeface="Times New Roman"/>
+        <a:font script="Hebr" typeface="Times New Roman"/>
+        <a:font script="Thai" typeface="Angsana New"/>
+        <a:font script="Ethi" typeface="Nyala"/>
+        <a:font script="Beng" typeface="Vrinda"/>
+        <a:font script="Gujr" typeface="Shruti"/>
+        <a:font script="Khmr" typeface="MoolBoran"/>
+        <a:font script="Knda" typeface="Tunga"/>
+        <a:font script="Guru" typeface="Raavi"/>
+        <a:font script="Cans" typeface="Euphemia"/>
+        <a:font script="Cher" typeface="Plantagenet Cherokee"/>
+        <a:font script="Yiii" typeface="Microsoft Yi Baiti"/>
+        <a:font script="Tibt" typeface="Microsoft Himalaya"/>
+        <a:font script="Thaa" typeface="MV Boli"/>
+        <a:font script="Deva" typeface="Mangal"/>
+        <a:font script="Telu" typeface="Gautami"/>
+        <a:font script="Taml" typeface="Latha"/>
+        <a:font script="Syrc" typeface="Estrangelo Edessa"/>
+        <a:font script="Orya" typeface="Kalinga"/>
+        <a:font script="Mlym" typeface="Kartika"/>
+        <a:font script="Laoo" typeface="DokChampa"/>
+        <a:font script="Sinh" typeface="Iskoola Pota"/>
+        <a:font script="Mong" typeface="Mongolian Baiti"/>
+        <a:font script="Viet" typeface="Times New Roman"/>
+        <a:font script="Uigh" typeface="Microsoft Uighur"/>
+        <a:font script="Geor" typeface="Sylfaen"/>
+      </a:majorFont>
+      <a:minorFont>
+        <a:latin typeface="Roboto"/>
+        <a:ea typeface=""/>
+        <a:cs typeface=""/>
+        <a:font script="Jpan" typeface="ＭＳ Ｐゴシック"/>
+        <a:font script="Hang" typeface="맑은 고딕"/>
+        <a:font script="Hans" typeface="宋体"/>
+        <a:font script="Hant" typeface="新細明體"/>
+        <a:font script="Arab" typeface="Arial"/>
+        <a:font script="Hebr" typeface="Arial"/>
+        <a:font script="Thai" typeface="Cordia New"/>
+        <a:font script="Ethi" typeface="Nyala"/>
+        <a:font script="Beng" typeface="Vrinda"/>
+        <a:font script="Gujr" typeface="Shruti"/>
+        <a:font script="Khmr" typeface="DaunPenh"/>
+        <a:font script="Knda" typeface="Tunga"/>
+        <a:font script="Guru" typeface="Raavi"/>
+        <a:font script="Cans" typeface="Euphemia"/>
+        <a:font script="Cher" typeface="Plantagenet Cherokee"/>
+        <a:font script="Yiii" typeface="Microsoft Yi Baiti"/>
+        <a:font script="Tibt" typeface="Microsoft Himalaya"/>
+        <a:font script="Thaa" typeface="MV Boli"/>
+        <a:font script="Deva" typeface="Mangal"/>
+        <a:font script="Telu" typeface="Gautami"/>
+        <a:font script="Taml" typeface="Latha"/>
+        <a:font script="Syrc" typeface="Estrangelo Edessa"/>
+        <a:font script="Orya" typeface="Kalinga"/>
+        <a:font script="Mlym" typeface="Kartika"/>
+        <a:font script="Laoo" typeface="DokChampa"/>
+        <a:font script="Sinh" typeface="Iskoola Pota"/>
+        <a:font script="Mong" typeface="Mongolian Baiti"/>
+        <a:font script="Viet" typeface="Arial"/>
+        <a:font script="Uigh" typeface="Microsoft Uighur"/>
+        <a:font script="Geor" typeface="Sylfaen"/>
+      </a:minorFont>
+    </a:fontScheme>
+    <a:fmtScheme name="Office">
+      <a:fillStyleLst>
+        <a:solidFill>
+          <a:schemeClr val="phClr"/>
+        </a:solidFill>
+        <a:gradFill rotWithShape="1">
+          <a:gsLst>
+            <a:gs pos="0">
+              <a:schemeClr val="phClr">
+                <a:tint val="50000"/>
+                <a:satMod val="300000"/>
+              </a:schemeClr>
+            </a:gs>
+            <a:gs pos="35000">
+              <a:schemeClr val="phClr">
+                <a:tint val="37000"/>
+                <a:satMod val="300000"/>
+              </a:schemeClr>
+            </a:gs>
+            <a:gs pos="100000">
+              <a:schemeClr val="phClr">
+                <a:tint val="15000"/>
+                <a:satMod val="350000"/>
+              </a:schemeClr>
+            </a:gs>
+          </a:gsLst>
+          <a:lin ang="16200000" scaled="1"/>
+        </a:gradFill>
+        <a:gradFill rotWithShape="1">
+          <a:gsLst>
+            <a:gs pos="0">
+              <a:schemeClr val="phClr">
+                <a:tint val="100000"/>
+                <a:shade val="100000"/>
+                <a:satMod val="130000"/>
+              </a:schemeClr>
+            </a:gs>
+            <a:gs pos="100000">
+              <a:schemeClr val="phClr">
+                <a:tint val="50000"/>
+                <a:shade val="100000"/>
+                <a:satMod val="350000"/>
+              </a:schemeClr>
+            </a:gs>
+          </a:gsLst>
+          <a:lin ang="16200000" scaled="0"/>
+        </a:gradFill>
+      </a:fillStyleLst>
+      <a:lnStyleLst>
+        <a:ln w="9525" cap="flat" cmpd="sng" algn="ctr">
+          <a:solidFill>
+            <a:schemeClr val="phClr">
+              <a:shade val="95000"/>
+              <a:satMod val="105000"/>
+            </a:schemeClr>
+          </a:solidFill>
+          <a:prstDash val="solid"/>
+        </a:ln>
+        <a:ln w="25400" cap="flat" cmpd="sng" algn="ctr">
+          <a:solidFill>
+            <a:schemeClr val="phClr"/>
+          </a:solidFill>
+          <a:prstDash val="solid"/>
+        </a:ln>
+        <a:ln w="38100" cap="flat" cmpd="sng" algn="ctr">
+          <a:solidFill>
+            <a:schemeClr val="phClr"/>
+          </a:solidFill>
+          <a:prstDash val="solid"/>
+        </a:ln>
+      </a:lnStyleLst>
+      <a:effectStyleLst>
+        <a:effectStyle>
+          <a:effectLst>
+            <a:outerShdw blurRad="40000" dist="20000" dir="5400000" rotWithShape="0">
+              <a:srgbClr val="000000">
+                <a:alpha val="38000"/>
+              </a:srgbClr>
+            </a:outerShdw>
+          </a:effectLst>
+        </a:effectStyle>
+        <a:effectStyle>
+          <a:effectLst>
+            <a:outerShdw blurRad="40000" dist="23000" dir="5400000" rotWithShape="0">
+              <a:srgbClr val="000000">
+                <a:alpha val="35000"/>
+              </a:srgbClr>
+            </a:outerShdw>
+          </a:effectLst>
+        </a:effectStyle>
+        <a:effectStyle>
+          <a:effectLst>
+            <a:outerShdw blurRad="40000" dist="23000" dir="5400000" rotWithShape="0">
+              <a:srgbClr val="000000">
+                <a:alpha val="35000"/>
+              </a:srgbClr>
+            </a:outerShdw>
+          </a:effectLst>
+          <a:scene3d>
+            <a:camera prst="orthographicFront">
+              <a:rot lat="0" lon="0" rev="0"/>
+            </a:camera>
+            <a:lightRig rig="threePt" dir="t">
+              <a:rot lat="0" lon="0" rev="1200000"/>
+            </a:lightRig>
+          </a:scene3d>
+          <a:sp3d>
+            <a:bevelT w="63500" h="25400"/>
+          </a:sp3d>
+        </a:effectStyle>
+      </a:effectStyleLst>
+      <a:bgFillStyleLst>
+        <a:solidFill>
+          <a:schemeClr val="phClr"/>
+        </a:solidFill>
+        <a:gradFill rotWithShape="1">
+          <a:gsLst>
+            <a:gs pos="0">
+              <a:schemeClr val="phClr">
+                <a:tint val="40000"/>
+                <a:satMod val="350000"/>
+              </a:schemeClr>
+            </a:gs>
+            <a:gs pos="40000">
+              <a:schemeClr val="phClr">
+                <a:tint val="45000"/>
+                <a:shade val="99000"/>
+                <a:satMod val="350000"/>
+              </a:schemeClr>
+            </a:gs>
+            <a:gs pos="100000">
+              <a:schemeClr val="phClr">
+                <a:shade val="20000"/>
+                <a:satMod val="255000"/>
+              </a:schemeClr>
+            </a:gs>
+          </a:gsLst>
+          <a:path path="circle">
+            <a:fillToRect l="50000" t="-80000" r="50000" b="180000"/>
+          </a:path>
+        </a:gradFill>
+        <a:gradFill rotWithShape="1">
+          <a:gsLst>
+            <a:gs pos="0">
+              <a:schemeClr val="phClr">
+                <a:tint val="80000"/>
+                <a:satMod val="300000"/>
+              </a:schemeClr>
+            </a:gs>
+            <a:gs pos="100000">
+              <a:schemeClr val="phClr">
+                <a:shade val="30000"/>
+                <a:satMod val="200000"/>
+              </a:schemeClr>
+            </a:gs>
+          </a:gsLst>
+          <a:path path="circle">
+            <a:fillToRect l="50000" t="50000" r="50000" b="50000"/>
+          </a:path>
+        </a:gradFill>
+      </a:bgFillStyleLst>
+    </a:fmtScheme>
+  </a:themeElements>
+  <a:objectDefaults>
+    <a:spDef>
+      <a:spPr/>
+      <a:bodyPr/>
+      <a:lstStyle/>
+      <a:style>
+        <a:lnRef idx="1">
+          <a:schemeClr val="accent1"/>
+        </a:lnRef>
+        <a:fillRef idx="3">
+          <a:schemeClr val="accent1"/>
+        </a:fillRef>
+        <a:effectRef idx="2">
+          <a:schemeClr val="accent1"/>
+        </a:effectRef>
+        <a:fontRef idx="minor">
+          <a:schemeClr val="lt1"/>
+        </a:fontRef>
+      </a:style>
+    </a:spDef>
+    <a:lnDef>
+      <a:spPr/>
+      <a:bodyPr/>
+      <a:lstStyle/>
+      <a:style>
+        <a:lnRef idx="2">
+          <a:schemeClr val="accent1"/>
+        </a:lnRef>
+        <a:fillRef idx="0">
+          <a:schemeClr val="accent1"/>
+        </a:fillRef>
+        <a:effectRef idx="1">
+          <a:schemeClr val="accent1"/>
+        </a:effectRef>
+        <a:fontRef idx="minor">
+          <a:schemeClr val="tx1"/>
+        </a:fontRef>
+      </a:style>
+    </a:lnDef>
+  </a:objectDefaults>
+  <a:extraClrSchemeLst/>
+</a:theme>
+</file>
+
+<file path=ppt/theme/theme2.xml><?xml version="1.0" encoding="utf-8"?>
 <a:theme xmlns:a="http://schemas.openxmlformats.org/drawingml/2006/main" name="Office Theme">
   <a:themeElements>
     <a:clrScheme name="Office">

</xml_diff>